<commit_message>
docs: add ordering & pixelated-image question slides, fix four-types wording
Co-Authored-By: Claude Opus 4.8 (1M context) <noreply@anthropic.com>
</commit_message>
<xml_diff>
--- a/docs/cogniro-presentation.pptx
+++ b/docs/cogniro-presentation.pptx
@@ -26,6 +26,8 @@
     <p:sldId id="274" r:id="rId25"/>
     <p:sldId id="275" r:id="rId26"/>
     <p:sldId id="276" r:id="rId27"/>
+    <p:sldId id="277" r:id="rId28"/>
+    <p:sldId id="278" r:id="rId29"/>
   </p:sldIdLst>
   <p:sldSz cx="12192119" cy="6858000" type="screen4x3"/>
   <p:notesSz cx="6858000" cy="9144000"/>
@@ -3444,7 +3446,7 @@
                 </a:solidFill>
                 <a:latin typeface="Calibri"/>
               </a:rPr>
-              <a:t>10 / 21</a:t>
+              <a:t>10 / 23</a:t>
             </a:r>
           </a:p>
         </p:txBody>
@@ -3685,7 +3687,7 @@
                 </a:solidFill>
                 <a:latin typeface="Calibri"/>
               </a:rPr>
-              <a:t>Zaznaczasz w edytorze wszystkie poprawne odpowiedzi. Uczestnik widzi pola z checkboxami — może wybrać dowolnie wiele.</a:t>
+              <a:t>Zaznaczasz w edytorze wszystkie poprawne odpowiedzi. Uczestnik widzi pola z checkboxami - może wybrać dowolnie wiele.</a:t>
             </a:r>
           </a:p>
         </p:txBody>
@@ -3869,7 +3871,7 @@
                 </a:solidFill>
                 <a:latin typeface="Calibri"/>
               </a:rPr>
-              <a:t>11 / 21</a:t>
+              <a:t>11 / 23</a:t>
             </a:r>
           </a:p>
         </p:txBody>
@@ -4110,7 +4112,7 @@
                 </a:solidFill>
                 <a:latin typeface="Calibri"/>
               </a:rPr>
-              <a:t>Najkrótsza forma — w edytorze tylko przełącznik Prawda/Fałsz. Uczestnik dostaje dwa duże przyciski i wybiera jedno kliknięcie.</a:t>
+              <a:t>Najkrótsza forma - w edytorze tylko przełącznik Prawda/Fałsz. Uczestnik dostaje dwa duże przyciski i wybiera jedno kliknięcie.</a:t>
             </a:r>
           </a:p>
         </p:txBody>
@@ -4294,7 +4296,7 @@
                 </a:solidFill>
                 <a:latin typeface="Calibri"/>
               </a:rPr>
-              <a:t>12 / 21</a:t>
+              <a:t>12 / 23</a:t>
             </a:r>
           </a:p>
         </p:txBody>
@@ -4656,93 +4658,14 @@
       </p:sp>
       <p:sp>
         <p:nvSpPr>
-          <p:cNvPr id="4" name="Rounded Rectangle 3"/>
-          <p:cNvSpPr/>
-          <p:nvPr/>
-        </p:nvSpPr>
-        <p:spPr>
-          <a:xfrm>
-            <a:off x="324000" y="180000"/>
-            <a:ext cx="1080000" cy="360000"/>
-          </a:xfrm>
-          <a:prstGeom prst="roundRect">
-            <a:avLst/>
-          </a:prstGeom>
-          <a:solidFill>
-            <a:srgbClr val="E8B44F"/>
-          </a:solidFill>
-          <a:ln>
-            <a:noFill/>
-          </a:ln>
-          <a:effectLst/>
-        </p:spPr>
-        <p:style>
-          <a:lnRef idx="1">
-            <a:schemeClr val="accent1"/>
-          </a:lnRef>
-          <a:fillRef idx="3">
-            <a:schemeClr val="accent1"/>
-          </a:fillRef>
-          <a:effectRef idx="2">
-            <a:schemeClr val="accent1"/>
-          </a:effectRef>
-          <a:fontRef idx="minor">
-            <a:schemeClr val="lt1"/>
-          </a:fontRef>
-        </p:style>
-        <p:txBody>
-          <a:bodyPr rtlCol="0" anchor="ctr"/>
-          <a:lstStyle/>
-          <a:p>
-            <a:pPr algn="ctr"/>
-          </a:p>
-        </p:txBody>
-      </p:sp>
-      <p:sp>
-        <p:nvSpPr>
-          <p:cNvPr id="5" name="TextBox 4"/>
+          <p:cNvPr id="4" name="TextBox 3"/>
           <p:cNvSpPr txBox="1"/>
           <p:nvPr/>
         </p:nvSpPr>
         <p:spPr>
           <a:xfrm>
-            <a:off x="324000" y="244800"/>
-            <a:ext cx="1080000" cy="251999"/>
-          </a:xfrm>
-          <a:prstGeom prst="rect">
-            <a:avLst/>
-          </a:prstGeom>
-          <a:noFill/>
-        </p:spPr>
-        <p:txBody>
-          <a:bodyPr wrap="square" lIns="0" rIns="0" tIns="0" bIns="0">
-            <a:spAutoFit/>
-          </a:bodyPr>
-          <a:lstStyle/>
-          <a:p>
-            <a:pPr algn="ctr"/>
-            <a:r>
-              <a:rPr sz="1200" b="1" i="0">
-                <a:solidFill>
-                  <a:srgbClr val="FFFFFF"/>
-                </a:solidFill>
-                <a:latin typeface="Calibri"/>
-              </a:rPr>
-              <a:t>KROK 8</a:t>
-            </a:r>
-          </a:p>
-        </p:txBody>
-      </p:sp>
-      <p:sp>
-        <p:nvSpPr>
-          <p:cNvPr id="6" name="TextBox 5"/>
-          <p:cNvSpPr txBox="1"/>
-          <p:nvPr/>
-        </p:nvSpPr>
-        <p:spPr>
-          <a:xfrm>
-            <a:off x="1548000" y="198000"/>
-            <a:ext cx="10032119" cy="432000"/>
+            <a:off x="324000" y="198000"/>
+            <a:ext cx="11472119" cy="432000"/>
           </a:xfrm>
           <a:prstGeom prst="rect">
             <a:avLst/>
@@ -4763,14 +4686,14 @@
                 </a:solidFill>
                 <a:latin typeface="Calibri"/>
               </a:rPr>
-              <a:t>Uruchamia quiz dla uczestników</a:t>
-            </a:r>
-          </a:p>
-        </p:txBody>
-      </p:sp>
-      <p:sp>
-        <p:nvSpPr>
-          <p:cNvPr id="7" name="TextBox 6"/>
+              <a:t>Typ pytania: Porządkowanie</a:t>
+            </a:r>
+          </a:p>
+        </p:txBody>
+      </p:sp>
+      <p:sp>
+        <p:nvSpPr>
+          <p:cNvPr id="5" name="TextBox 4"/>
           <p:cNvSpPr txBox="1"/>
           <p:nvPr/>
         </p:nvSpPr>
@@ -4798,21 +4721,56 @@
                 </a:solidFill>
                 <a:latin typeface="Calibri"/>
               </a:rPr>
-              <a:t>13 / 21</a:t>
-            </a:r>
-          </a:p>
-        </p:txBody>
-      </p:sp>
-      <p:sp>
-        <p:nvSpPr>
-          <p:cNvPr id="8" name="Rectangle 7"/>
+              <a:t>13 / 23</a:t>
+            </a:r>
+          </a:p>
+        </p:txBody>
+      </p:sp>
+      <p:sp>
+        <p:nvSpPr>
+          <p:cNvPr id="6" name="TextBox 5"/>
+          <p:cNvSpPr txBox="1"/>
+          <p:nvPr/>
+        </p:nvSpPr>
+        <p:spPr>
+          <a:xfrm>
+            <a:off x="288000" y="917999"/>
+            <a:ext cx="7380000" cy="251999"/>
+          </a:xfrm>
+          <a:prstGeom prst="rect">
+            <a:avLst/>
+          </a:prstGeom>
+          <a:noFill/>
+        </p:spPr>
+        <p:txBody>
+          <a:bodyPr wrap="square" lIns="0" rIns="0" tIns="0" bIns="0">
+            <a:spAutoFit/>
+          </a:bodyPr>
+          <a:lstStyle/>
+          <a:p>
+            <a:pPr algn="l"/>
+            <a:r>
+              <a:rPr sz="1300" b="1" i="0">
+                <a:solidFill>
+                  <a:srgbClr val="1F4E79"/>
+                </a:solidFill>
+                <a:latin typeface="Calibri"/>
+              </a:rPr>
+              <a:t>Tak wygląda edycja</a:t>
+            </a:r>
+          </a:p>
+        </p:txBody>
+      </p:sp>
+      <p:sp>
+        <p:nvSpPr>
+          <p:cNvPr id="7" name="Rectangle 6"/>
           <p:cNvSpPr/>
           <p:nvPr/>
         </p:nvSpPr>
         <p:spPr>
           <a:xfrm>
-            <a:off x="2251259" y="1015200"/>
-            <a:ext cx="7776000" cy="4860000"/>
+            <a:off x="1004409" y="1231200"/>
+            <a:ext cx="6033582" cy="4536000"/>
           </a:xfrm>
           <a:prstGeom prst="rect">
             <a:avLst/>
@@ -4849,7 +4807,7 @@
       </p:sp>
       <p:pic>
         <p:nvPicPr>
-          <p:cNvPr id="9" name="Picture 8" descr="admin-quiz-active.png"/>
+          <p:cNvPr id="8" name="Picture 7" descr="editor-ordering-card.png"/>
           <p:cNvPicPr>
             <a:picLocks noChangeAspect="1"/>
           </p:cNvPicPr>
@@ -4863,8 +4821,8 @@
         </p:blipFill>
         <p:spPr>
           <a:xfrm>
-            <a:off x="2208059" y="972000"/>
-            <a:ext cx="7776000" cy="4860000"/>
+            <a:off x="961209" y="1188000"/>
+            <a:ext cx="6033582" cy="4536000"/>
           </a:xfrm>
           <a:prstGeom prst="rect">
             <a:avLst/>
@@ -4873,14 +4831,14 @@
       </p:pic>
       <p:sp>
         <p:nvSpPr>
-          <p:cNvPr id="10" name="TextBox 9"/>
+          <p:cNvPr id="9" name="TextBox 8"/>
           <p:cNvSpPr txBox="1"/>
           <p:nvPr/>
         </p:nvSpPr>
         <p:spPr>
           <a:xfrm>
-            <a:off x="432000" y="5976000"/>
-            <a:ext cx="11328119" cy="720000"/>
+            <a:off x="7920000" y="917999"/>
+            <a:ext cx="3960000" cy="251999"/>
           </a:xfrm>
           <a:prstGeom prst="rect">
             <a:avLst/>
@@ -4893,15 +4851,118 @@
           </a:bodyPr>
           <a:lstStyle/>
           <a:p>
-            <a:pPr algn="ctr"/>
-            <a:r>
-              <a:rPr sz="1800" b="0" i="0">
+            <a:pPr algn="l"/>
+            <a:r>
+              <a:rPr sz="1300" b="1" i="0">
+                <a:solidFill>
+                  <a:srgbClr val="1F4E79"/>
+                </a:solidFill>
+                <a:latin typeface="Calibri"/>
+              </a:rPr>
+              <a:t>Tak widzi uczestnik</a:t>
+            </a:r>
+          </a:p>
+        </p:txBody>
+      </p:sp>
+      <p:sp>
+        <p:nvSpPr>
+          <p:cNvPr id="10" name="Rectangle 9"/>
+          <p:cNvSpPr/>
+          <p:nvPr/>
+        </p:nvSpPr>
+        <p:spPr>
+          <a:xfrm>
+            <a:off x="7963200" y="2261700"/>
+            <a:ext cx="3960000" cy="2475000"/>
+          </a:xfrm>
+          <a:prstGeom prst="rect">
+            <a:avLst/>
+          </a:prstGeom>
+          <a:solidFill>
+            <a:srgbClr val="D8D8D8"/>
+          </a:solidFill>
+          <a:ln>
+            <a:noFill/>
+          </a:ln>
+          <a:effectLst/>
+        </p:spPr>
+        <p:style>
+          <a:lnRef idx="1">
+            <a:schemeClr val="accent1"/>
+          </a:lnRef>
+          <a:fillRef idx="3">
+            <a:schemeClr val="accent1"/>
+          </a:fillRef>
+          <a:effectRef idx="2">
+            <a:schemeClr val="accent1"/>
+          </a:effectRef>
+          <a:fontRef idx="minor">
+            <a:schemeClr val="lt1"/>
+          </a:fontRef>
+        </p:style>
+        <p:txBody>
+          <a:bodyPr rtlCol="0" anchor="ctr"/>
+          <a:lstStyle/>
+          <a:p>
+            <a:pPr algn="ctr"/>
+          </a:p>
+        </p:txBody>
+      </p:sp>
+      <p:pic>
+        <p:nvPicPr>
+          <p:cNvPr id="11" name="Picture 10" descr="play-ordering.png"/>
+          <p:cNvPicPr>
+            <a:picLocks noChangeAspect="1"/>
+          </p:cNvPicPr>
+          <p:nvPr/>
+        </p:nvPicPr>
+        <p:blipFill>
+          <a:blip r:embed="rId3"/>
+          <a:stretch>
+            <a:fillRect/>
+          </a:stretch>
+        </p:blipFill>
+        <p:spPr>
+          <a:xfrm>
+            <a:off x="7920000" y="2218500"/>
+            <a:ext cx="3960000" cy="2475000"/>
+          </a:xfrm>
+          <a:prstGeom prst="rect">
+            <a:avLst/>
+          </a:prstGeom>
+        </p:spPr>
+      </p:pic>
+      <p:sp>
+        <p:nvSpPr>
+          <p:cNvPr id="12" name="TextBox 11"/>
+          <p:cNvSpPr txBox="1"/>
+          <p:nvPr/>
+        </p:nvSpPr>
+        <p:spPr>
+          <a:xfrm>
+            <a:off x="288000" y="5976000"/>
+            <a:ext cx="11616119" cy="720000"/>
+          </a:xfrm>
+          <a:prstGeom prst="rect">
+            <a:avLst/>
+          </a:prstGeom>
+          <a:noFill/>
+        </p:spPr>
+        <p:txBody>
+          <a:bodyPr wrap="square" lIns="0" rIns="0" tIns="0" bIns="0">
+            <a:spAutoFit/>
+          </a:bodyPr>
+          <a:lstStyle/>
+          <a:p>
+            <a:pPr algn="ctr"/>
+            <a:r>
+              <a:rPr sz="1600" b="0" i="1">
                 <a:solidFill>
                   <a:srgbClr val="1A1A1A"/>
                 </a:solidFill>
                 <a:latin typeface="Calibri"/>
               </a:rPr>
-              <a:t>Quiz dostaje status „Aktywny”, a obok pojawia się duży przycisk „Pokaż kod QR”.</a:t>
+              <a:t>W edytorze podajesz elementy i ich poprawną kolejność. Uczestnik przeciąga pozycje na liście, układa je we właściwej kolejności i zatwierdza.</a:t>
             </a:r>
           </a:p>
         </p:txBody>
@@ -5022,93 +5083,14 @@
       </p:sp>
       <p:sp>
         <p:nvSpPr>
-          <p:cNvPr id="4" name="Rounded Rectangle 3"/>
-          <p:cNvSpPr/>
-          <p:nvPr/>
-        </p:nvSpPr>
-        <p:spPr>
-          <a:xfrm>
-            <a:off x="324000" y="180000"/>
-            <a:ext cx="1080000" cy="360000"/>
-          </a:xfrm>
-          <a:prstGeom prst="roundRect">
-            <a:avLst/>
-          </a:prstGeom>
-          <a:solidFill>
-            <a:srgbClr val="E8B44F"/>
-          </a:solidFill>
-          <a:ln>
-            <a:noFill/>
-          </a:ln>
-          <a:effectLst/>
-        </p:spPr>
-        <p:style>
-          <a:lnRef idx="1">
-            <a:schemeClr val="accent1"/>
-          </a:lnRef>
-          <a:fillRef idx="3">
-            <a:schemeClr val="accent1"/>
-          </a:fillRef>
-          <a:effectRef idx="2">
-            <a:schemeClr val="accent1"/>
-          </a:effectRef>
-          <a:fontRef idx="minor">
-            <a:schemeClr val="lt1"/>
-          </a:fontRef>
-        </p:style>
-        <p:txBody>
-          <a:bodyPr rtlCol="0" anchor="ctr"/>
-          <a:lstStyle/>
-          <a:p>
-            <a:pPr algn="ctr"/>
-          </a:p>
-        </p:txBody>
-      </p:sp>
-      <p:sp>
-        <p:nvSpPr>
-          <p:cNvPr id="5" name="TextBox 4"/>
+          <p:cNvPr id="4" name="TextBox 3"/>
           <p:cNvSpPr txBox="1"/>
           <p:nvPr/>
         </p:nvSpPr>
         <p:spPr>
           <a:xfrm>
-            <a:off x="324000" y="244800"/>
-            <a:ext cx="1080000" cy="251999"/>
-          </a:xfrm>
-          <a:prstGeom prst="rect">
-            <a:avLst/>
-          </a:prstGeom>
-          <a:noFill/>
-        </p:spPr>
-        <p:txBody>
-          <a:bodyPr wrap="square" lIns="0" rIns="0" tIns="0" bIns="0">
-            <a:spAutoFit/>
-          </a:bodyPr>
-          <a:lstStyle/>
-          <a:p>
-            <a:pPr algn="ctr"/>
-            <a:r>
-              <a:rPr sz="1200" b="1" i="0">
-                <a:solidFill>
-                  <a:srgbClr val="FFFFFF"/>
-                </a:solidFill>
-                <a:latin typeface="Calibri"/>
-              </a:rPr>
-              <a:t>KROK 9</a:t>
-            </a:r>
-          </a:p>
-        </p:txBody>
-      </p:sp>
-      <p:sp>
-        <p:nvSpPr>
-          <p:cNvPr id="6" name="TextBox 5"/>
-          <p:cNvSpPr txBox="1"/>
-          <p:nvPr/>
-        </p:nvSpPr>
-        <p:spPr>
-          <a:xfrm>
-            <a:off x="1548000" y="198000"/>
-            <a:ext cx="10032119" cy="432000"/>
+            <a:off x="324000" y="198000"/>
+            <a:ext cx="11472119" cy="432000"/>
           </a:xfrm>
           <a:prstGeom prst="rect">
             <a:avLst/>
@@ -5129,14 +5111,14 @@
                 </a:solidFill>
                 <a:latin typeface="Calibri"/>
               </a:rPr>
-              <a:t>Pokazuje plansze z kodem QR</a:t>
-            </a:r>
-          </a:p>
-        </p:txBody>
-      </p:sp>
-      <p:sp>
-        <p:nvSpPr>
-          <p:cNvPr id="7" name="TextBox 6"/>
+              <a:t>Typ pytania: Obraz pikselowany</a:t>
+            </a:r>
+          </a:p>
+        </p:txBody>
+      </p:sp>
+      <p:sp>
+        <p:nvSpPr>
+          <p:cNvPr id="5" name="TextBox 4"/>
           <p:cNvSpPr txBox="1"/>
           <p:nvPr/>
         </p:nvSpPr>
@@ -5164,21 +5146,56 @@
                 </a:solidFill>
                 <a:latin typeface="Calibri"/>
               </a:rPr>
-              <a:t>14 / 21</a:t>
-            </a:r>
-          </a:p>
-        </p:txBody>
-      </p:sp>
-      <p:sp>
-        <p:nvSpPr>
-          <p:cNvPr id="8" name="Rectangle 7"/>
+              <a:t>14 / 23</a:t>
+            </a:r>
+          </a:p>
+        </p:txBody>
+      </p:sp>
+      <p:sp>
+        <p:nvSpPr>
+          <p:cNvPr id="6" name="TextBox 5"/>
+          <p:cNvSpPr txBox="1"/>
+          <p:nvPr/>
+        </p:nvSpPr>
+        <p:spPr>
+          <a:xfrm>
+            <a:off x="288000" y="917999"/>
+            <a:ext cx="7380000" cy="251999"/>
+          </a:xfrm>
+          <a:prstGeom prst="rect">
+            <a:avLst/>
+          </a:prstGeom>
+          <a:noFill/>
+        </p:spPr>
+        <p:txBody>
+          <a:bodyPr wrap="square" lIns="0" rIns="0" tIns="0" bIns="0">
+            <a:spAutoFit/>
+          </a:bodyPr>
+          <a:lstStyle/>
+          <a:p>
+            <a:pPr algn="l"/>
+            <a:r>
+              <a:rPr sz="1300" b="1" i="0">
+                <a:solidFill>
+                  <a:srgbClr val="1F4E79"/>
+                </a:solidFill>
+                <a:latin typeface="Calibri"/>
+              </a:rPr>
+              <a:t>Tak wygląda edycja</a:t>
+            </a:r>
+          </a:p>
+        </p:txBody>
+      </p:sp>
+      <p:sp>
+        <p:nvSpPr>
+          <p:cNvPr id="7" name="Rectangle 6"/>
           <p:cNvSpPr/>
           <p:nvPr/>
         </p:nvSpPr>
         <p:spPr>
           <a:xfrm>
-            <a:off x="2251259" y="1015200"/>
-            <a:ext cx="7776000" cy="4860000"/>
+            <a:off x="1549434" y="1231200"/>
+            <a:ext cx="4943531" cy="4536000"/>
           </a:xfrm>
           <a:prstGeom prst="rect">
             <a:avLst/>
@@ -5215,7 +5232,7 @@
       </p:sp>
       <p:pic>
         <p:nvPicPr>
-          <p:cNvPr id="9" name="Picture 8" descr="presenter-active.png"/>
+          <p:cNvPr id="8" name="Picture 7" descr="editor-pixelate-card.png"/>
           <p:cNvPicPr>
             <a:picLocks noChangeAspect="1"/>
           </p:cNvPicPr>
@@ -5229,8 +5246,8 @@
         </p:blipFill>
         <p:spPr>
           <a:xfrm>
-            <a:off x="2208059" y="972000"/>
-            <a:ext cx="7776000" cy="4860000"/>
+            <a:off x="1506234" y="1188000"/>
+            <a:ext cx="4943531" cy="4536000"/>
           </a:xfrm>
           <a:prstGeom prst="rect">
             <a:avLst/>
@@ -5239,14 +5256,14 @@
       </p:pic>
       <p:sp>
         <p:nvSpPr>
-          <p:cNvPr id="10" name="TextBox 9"/>
+          <p:cNvPr id="9" name="TextBox 8"/>
           <p:cNvSpPr txBox="1"/>
           <p:nvPr/>
         </p:nvSpPr>
         <p:spPr>
           <a:xfrm>
-            <a:off x="432000" y="5976000"/>
-            <a:ext cx="11328119" cy="720000"/>
+            <a:off x="7920000" y="917999"/>
+            <a:ext cx="3960000" cy="251999"/>
           </a:xfrm>
           <a:prstGeom prst="rect">
             <a:avLst/>
@@ -5259,15 +5276,118 @@
           </a:bodyPr>
           <a:lstStyle/>
           <a:p>
-            <a:pPr algn="ctr"/>
-            <a:r>
-              <a:rPr sz="1800" b="0" i="0">
+            <a:pPr algn="l"/>
+            <a:r>
+              <a:rPr sz="1300" b="1" i="0">
+                <a:solidFill>
+                  <a:srgbClr val="1F4E79"/>
+                </a:solidFill>
+                <a:latin typeface="Calibri"/>
+              </a:rPr>
+              <a:t>Tak widzi uczestnik</a:t>
+            </a:r>
+          </a:p>
+        </p:txBody>
+      </p:sp>
+      <p:sp>
+        <p:nvSpPr>
+          <p:cNvPr id="10" name="Rectangle 9"/>
+          <p:cNvSpPr/>
+          <p:nvPr/>
+        </p:nvSpPr>
+        <p:spPr>
+          <a:xfrm>
+            <a:off x="7963200" y="2261700"/>
+            <a:ext cx="3960000" cy="2475000"/>
+          </a:xfrm>
+          <a:prstGeom prst="rect">
+            <a:avLst/>
+          </a:prstGeom>
+          <a:solidFill>
+            <a:srgbClr val="D8D8D8"/>
+          </a:solidFill>
+          <a:ln>
+            <a:noFill/>
+          </a:ln>
+          <a:effectLst/>
+        </p:spPr>
+        <p:style>
+          <a:lnRef idx="1">
+            <a:schemeClr val="accent1"/>
+          </a:lnRef>
+          <a:fillRef idx="3">
+            <a:schemeClr val="accent1"/>
+          </a:fillRef>
+          <a:effectRef idx="2">
+            <a:schemeClr val="accent1"/>
+          </a:effectRef>
+          <a:fontRef idx="minor">
+            <a:schemeClr val="lt1"/>
+          </a:fontRef>
+        </p:style>
+        <p:txBody>
+          <a:bodyPr rtlCol="0" anchor="ctr"/>
+          <a:lstStyle/>
+          <a:p>
+            <a:pPr algn="ctr"/>
+          </a:p>
+        </p:txBody>
+      </p:sp>
+      <p:pic>
+        <p:nvPicPr>
+          <p:cNvPr id="11" name="Picture 10" descr="play-pixelate.png"/>
+          <p:cNvPicPr>
+            <a:picLocks noChangeAspect="1"/>
+          </p:cNvPicPr>
+          <p:nvPr/>
+        </p:nvPicPr>
+        <p:blipFill>
+          <a:blip r:embed="rId3"/>
+          <a:stretch>
+            <a:fillRect/>
+          </a:stretch>
+        </p:blipFill>
+        <p:spPr>
+          <a:xfrm>
+            <a:off x="7920000" y="2218500"/>
+            <a:ext cx="3960000" cy="2475000"/>
+          </a:xfrm>
+          <a:prstGeom prst="rect">
+            <a:avLst/>
+          </a:prstGeom>
+        </p:spPr>
+      </p:pic>
+      <p:sp>
+        <p:nvSpPr>
+          <p:cNvPr id="12" name="TextBox 11"/>
+          <p:cNvSpPr txBox="1"/>
+          <p:nvPr/>
+        </p:nvSpPr>
+        <p:spPr>
+          <a:xfrm>
+            <a:off x="288000" y="5976000"/>
+            <a:ext cx="11616119" cy="720000"/>
+          </a:xfrm>
+          <a:prstGeom prst="rect">
+            <a:avLst/>
+          </a:prstGeom>
+          <a:noFill/>
+        </p:spPr>
+        <p:txBody>
+          <a:bodyPr wrap="square" lIns="0" rIns="0" tIns="0" bIns="0">
+            <a:spAutoFit/>
+          </a:bodyPr>
+          <a:lstStyle/>
+          <a:p>
+            <a:pPr algn="ctr"/>
+            <a:r>
+              <a:rPr sz="1600" b="0" i="1">
                 <a:solidFill>
                   <a:srgbClr val="1A1A1A"/>
                 </a:solidFill>
                 <a:latin typeface="Calibri"/>
               </a:rPr>
-              <a:t>Otwiera osobne okno do wyświetlenia na rzutniku — wielki QR, sześcioznakowy PIN i pełny link.</a:t>
+              <a:t>W edytorze wgrywasz obraz i dodajesz odpowiedzi, zaznaczając poprawną. Uczestnikowi obraz odsłania się stopniowo z pikseli, więc im szybciej go rozpozna, tym lepiej.</a:t>
             </a:r>
           </a:p>
         </p:txBody>
@@ -5460,7 +5580,7 @@
                 </a:solidFill>
                 <a:latin typeface="Calibri"/>
               </a:rPr>
-              <a:t>KROK 10</a:t>
+              <a:t>KROK 8</a:t>
             </a:r>
           </a:p>
         </p:txBody>
@@ -5495,7 +5615,7 @@
                 </a:solidFill>
                 <a:latin typeface="Calibri"/>
               </a:rPr>
-              <a:t>Uczestnik skanuje kod telefonem</a:t>
+              <a:t>Uruchamia quiz dla uczestników</a:t>
             </a:r>
           </a:p>
         </p:txBody>
@@ -5530,7 +5650,7 @@
                 </a:solidFill>
                 <a:latin typeface="Calibri"/>
               </a:rPr>
-              <a:t>15 / 21</a:t>
+              <a:t>15 / 23</a:t>
             </a:r>
           </a:p>
         </p:txBody>
@@ -5581,7 +5701,7 @@
       </p:sp>
       <p:pic>
         <p:nvPicPr>
-          <p:cNvPr id="9" name="Picture 8" descr="play-1-code.png"/>
+          <p:cNvPr id="9" name="Picture 8" descr="admin-quiz-active.png"/>
           <p:cNvPicPr>
             <a:picLocks noChangeAspect="1"/>
           </p:cNvPicPr>
@@ -5633,7 +5753,7 @@
                 </a:solidFill>
                 <a:latin typeface="Calibri"/>
               </a:rPr>
-              <a:t>Wchodzi na stronę dołączania. Kod ma już wpisany — wystarczy potwierdzić.</a:t>
+              <a:t>Quiz dostaje status „Aktywny”, a obok pojawia się duży przycisk „Pokaż kod QR”.</a:t>
             </a:r>
           </a:p>
         </p:txBody>
@@ -5826,7 +5946,7 @@
                 </a:solidFill>
                 <a:latin typeface="Calibri"/>
               </a:rPr>
-              <a:t>KROK 11</a:t>
+              <a:t>KROK 9</a:t>
             </a:r>
           </a:p>
         </p:txBody>
@@ -5861,7 +5981,7 @@
                 </a:solidFill>
                 <a:latin typeface="Calibri"/>
               </a:rPr>
-              <a:t>Uczestnik wybiera pseudonim</a:t>
+              <a:t>Pokazuje plansze z kodem QR</a:t>
             </a:r>
           </a:p>
         </p:txBody>
@@ -5896,7 +6016,7 @@
                 </a:solidFill>
                 <a:latin typeface="Calibri"/>
               </a:rPr>
-              <a:t>16 / 21</a:t>
+              <a:t>16 / 23</a:t>
             </a:r>
           </a:p>
         </p:txBody>
@@ -5947,7 +6067,7 @@
       </p:sp>
       <p:pic>
         <p:nvPicPr>
-          <p:cNvPr id="9" name="Picture 8" descr="play-2-nickname.png"/>
+          <p:cNvPr id="9" name="Picture 8" descr="presenter-active.png"/>
           <p:cNvPicPr>
             <a:picLocks noChangeAspect="1"/>
           </p:cNvPicPr>
@@ -5999,7 +6119,7 @@
                 </a:solidFill>
                 <a:latin typeface="Calibri"/>
               </a:rPr>
-              <a:t>Bez konta, bez maila — sam pseudonim wystarczy, by zacząć grę.</a:t>
+              <a:t>Otwiera osobne okno do wyświetlenia na rzutniku - wielki QR, sześcioznakowy PIN i pełny link.</a:t>
             </a:r>
           </a:p>
         </p:txBody>
@@ -6192,7 +6312,7 @@
                 </a:solidFill>
                 <a:latin typeface="Calibri"/>
               </a:rPr>
-              <a:t>KROK 12</a:t>
+              <a:t>KROK 10</a:t>
             </a:r>
           </a:p>
         </p:txBody>
@@ -6227,7 +6347,7 @@
                 </a:solidFill>
                 <a:latin typeface="Calibri"/>
               </a:rPr>
-              <a:t>Uczestnik odpowiada na pytania</a:t>
+              <a:t>Uczestnik skanuje kod telefonem</a:t>
             </a:r>
           </a:p>
         </p:txBody>
@@ -6262,7 +6382,7 @@
                 </a:solidFill>
                 <a:latin typeface="Calibri"/>
               </a:rPr>
-              <a:t>17 / 21</a:t>
+              <a:t>17 / 23</a:t>
             </a:r>
           </a:p>
         </p:txBody>
@@ -6313,7 +6433,7 @@
       </p:sp>
       <p:pic>
         <p:nvPicPr>
-          <p:cNvPr id="9" name="Picture 8" descr="play-3-question.png"/>
+          <p:cNvPr id="9" name="Picture 8" descr="play-1-code.png"/>
           <p:cNvPicPr>
             <a:picLocks noChangeAspect="1"/>
           </p:cNvPicPr>
@@ -6365,7 +6485,7 @@
                 </a:solidFill>
                 <a:latin typeface="Calibri"/>
               </a:rPr>
-              <a:t>Pytanie, licznik czasu, opcje do wyboru, duży przycisk zatwierdzenia. Wszystko pod telefon.</a:t>
+              <a:t>Wchodzi na stronę dołączania. Kod ma już wpisany - wystarczy potwierdzić.</a:t>
             </a:r>
           </a:p>
         </p:txBody>
@@ -6558,7 +6678,7 @@
                 </a:solidFill>
                 <a:latin typeface="Calibri"/>
               </a:rPr>
-              <a:t>KROK 13</a:t>
+              <a:t>KROK 11</a:t>
             </a:r>
           </a:p>
         </p:txBody>
@@ -6593,7 +6713,7 @@
                 </a:solidFill>
                 <a:latin typeface="Calibri"/>
               </a:rPr>
-              <a:t>Prowadzący widzi sesję na żywo</a:t>
+              <a:t>Uczestnik wybiera pseudonim</a:t>
             </a:r>
           </a:p>
         </p:txBody>
@@ -6628,7 +6748,7 @@
                 </a:solidFill>
                 <a:latin typeface="Calibri"/>
               </a:rPr>
-              <a:t>18 / 21</a:t>
+              <a:t>18 / 23</a:t>
             </a:r>
           </a:p>
         </p:txBody>
@@ -6679,7 +6799,7 @@
       </p:sp>
       <p:pic>
         <p:nvPicPr>
-          <p:cNvPr id="9" name="Picture 8" descr="admin-running.png"/>
+          <p:cNvPr id="9" name="Picture 8" descr="play-2-nickname.png"/>
           <p:cNvPicPr>
             <a:picLocks noChangeAspect="1"/>
           </p:cNvPicPr>
@@ -6731,7 +6851,7 @@
                 </a:solidFill>
                 <a:latin typeface="Calibri"/>
               </a:rPr>
-              <a:t>Lista uczestników aktualizuje się w czasie rzeczywistym — kto dołączył, kto odpowiedział, jakie ma punkty.</a:t>
+              <a:t>Bez konta, bez maila - sam pseudonim wystarczy, by zacząć grę.</a:t>
             </a:r>
           </a:p>
         </p:txBody>
@@ -6924,7 +7044,7 @@
                 </a:solidFill>
                 <a:latin typeface="Calibri"/>
               </a:rPr>
-              <a:t>KROK 14</a:t>
+              <a:t>KROK 12</a:t>
             </a:r>
           </a:p>
         </p:txBody>
@@ -6959,7 +7079,7 @@
                 </a:solidFill>
                 <a:latin typeface="Calibri"/>
               </a:rPr>
-              <a:t>Po zakończeniu — Statystyki</a:t>
+              <a:t>Uczestnik odpowiada na pytania</a:t>
             </a:r>
           </a:p>
         </p:txBody>
@@ -6994,7 +7114,7 @@
                 </a:solidFill>
                 <a:latin typeface="Calibri"/>
               </a:rPr>
-              <a:t>19 / 21</a:t>
+              <a:t>19 / 23</a:t>
             </a:r>
           </a:p>
         </p:txBody>
@@ -7045,7 +7165,7 @@
       </p:sp>
       <p:pic>
         <p:nvPicPr>
-          <p:cNvPr id="9" name="Picture 8" descr="admin-results.png"/>
+          <p:cNvPr id="9" name="Picture 8" descr="play-3-question.png"/>
           <p:cNvPicPr>
             <a:picLocks noChangeAspect="1"/>
           </p:cNvPicPr>
@@ -7097,7 +7217,7 @@
                 </a:solidFill>
                 <a:latin typeface="Calibri"/>
               </a:rPr>
-              <a:t>Każda sesja zapisana w tabeli. Po kliknięciu — szczegóły każdej osoby.</a:t>
+              <a:t>Pytanie, licznik czasu, opcje do wyboru, duży przycisk zatwierdzenia. Wszystko pod telefon.</a:t>
             </a:r>
           </a:p>
         </p:txBody>
@@ -7360,7 +7480,7 @@
                 </a:solidFill>
                 <a:latin typeface="Calibri"/>
               </a:rPr>
-              <a:t>2 / 21</a:t>
+              <a:t>2 / 23</a:t>
             </a:r>
           </a:p>
         </p:txBody>
@@ -7463,7 +7583,7 @@
                 </a:solidFill>
                 <a:latin typeface="Calibri"/>
               </a:rPr>
-              <a:t>Wchodzi na adres aplikacji, podaje hasło — i już jest w środku.</a:t>
+              <a:t>Wchodzi na adres aplikacji, podaje hasło - i już jest w środku.</a:t>
             </a:r>
           </a:p>
         </p:txBody>
@@ -7584,130 +7704,16 @@
       </p:sp>
       <p:sp>
         <p:nvSpPr>
-          <p:cNvPr id="4" name="TextBox 3"/>
-          <p:cNvSpPr txBox="1"/>
-          <p:nvPr/>
-        </p:nvSpPr>
-        <p:spPr>
-          <a:xfrm>
-            <a:off x="324000" y="198000"/>
-            <a:ext cx="11472119" cy="432000"/>
-          </a:xfrm>
-          <a:prstGeom prst="rect">
-            <a:avLst/>
-          </a:prstGeom>
-          <a:noFill/>
-        </p:spPr>
-        <p:txBody>
-          <a:bodyPr wrap="square" lIns="0" rIns="0" tIns="0" bIns="0">
-            <a:spAutoFit/>
-          </a:bodyPr>
-          <a:lstStyle/>
-          <a:p>
-            <a:pPr algn="l"/>
-            <a:r>
-              <a:rPr sz="2200" b="1" i="0">
-                <a:solidFill>
-                  <a:srgbClr val="FFFFFF"/>
-                </a:solidFill>
-                <a:latin typeface="Calibri"/>
-              </a:rPr>
-              <a:t>Dlaczego Cogniro</a:t>
-            </a:r>
-          </a:p>
-        </p:txBody>
-      </p:sp>
-      <p:sp>
-        <p:nvSpPr>
-          <p:cNvPr id="5" name="TextBox 4"/>
-          <p:cNvSpPr txBox="1"/>
-          <p:nvPr/>
-        </p:nvSpPr>
-        <p:spPr>
-          <a:xfrm>
-            <a:off x="11112119" y="270000"/>
-            <a:ext cx="900000" cy="216000"/>
-          </a:xfrm>
-          <a:prstGeom prst="rect">
-            <a:avLst/>
-          </a:prstGeom>
-          <a:noFill/>
-        </p:spPr>
-        <p:txBody>
-          <a:bodyPr wrap="square" lIns="0" rIns="0" tIns="0" bIns="0">
-            <a:spAutoFit/>
-          </a:bodyPr>
-          <a:lstStyle/>
-          <a:p>
-            <a:pPr algn="r"/>
-            <a:r>
-              <a:rPr sz="1000" b="0" i="0">
-                <a:solidFill>
-                  <a:srgbClr val="E8F0F9"/>
-                </a:solidFill>
-                <a:latin typeface="Calibri"/>
-              </a:rPr>
-              <a:t>20 / 21</a:t>
-            </a:r>
-          </a:p>
-        </p:txBody>
-      </p:sp>
-      <p:sp>
-        <p:nvSpPr>
-          <p:cNvPr id="6" name="Rounded Rectangle 5"/>
+          <p:cNvPr id="4" name="Rounded Rectangle 3"/>
           <p:cNvSpPr/>
           <p:nvPr/>
         </p:nvSpPr>
         <p:spPr>
           <a:xfrm>
-            <a:off x="540000" y="1260000"/>
-            <a:ext cx="3584039" cy="2340000"/>
+            <a:off x="324000" y="180000"/>
+            <a:ext cx="1080000" cy="360000"/>
           </a:xfrm>
           <a:prstGeom prst="roundRect">
-            <a:avLst/>
-          </a:prstGeom>
-          <a:solidFill>
-            <a:srgbClr val="E8F0F9"/>
-          </a:solidFill>
-          <a:ln>
-            <a:noFill/>
-          </a:ln>
-          <a:effectLst/>
-        </p:spPr>
-        <p:style>
-          <a:lnRef idx="1">
-            <a:schemeClr val="accent1"/>
-          </a:lnRef>
-          <a:fillRef idx="3">
-            <a:schemeClr val="accent1"/>
-          </a:fillRef>
-          <a:effectRef idx="2">
-            <a:schemeClr val="accent1"/>
-          </a:effectRef>
-          <a:fontRef idx="minor">
-            <a:schemeClr val="lt1"/>
-          </a:fontRef>
-        </p:style>
-        <p:txBody>
-          <a:bodyPr rtlCol="0" anchor="ctr"/>
-          <a:lstStyle/>
-          <a:p>
-            <a:pPr algn="ctr"/>
-          </a:p>
-        </p:txBody>
-      </p:sp>
-      <p:sp>
-        <p:nvSpPr>
-          <p:cNvPr id="7" name="Rectangle 6"/>
-          <p:cNvSpPr/>
-          <p:nvPr/>
-        </p:nvSpPr>
-        <p:spPr>
-          <a:xfrm>
-            <a:off x="540000" y="1260000"/>
-            <a:ext cx="3584039" cy="125999"/>
-          </a:xfrm>
-          <a:prstGeom prst="rect">
             <a:avLst/>
           </a:prstGeom>
           <a:solidFill>
@@ -7742,14 +7748,14 @@
       </p:sp>
       <p:sp>
         <p:nvSpPr>
-          <p:cNvPr id="8" name="TextBox 7"/>
+          <p:cNvPr id="5" name="TextBox 4"/>
           <p:cNvSpPr txBox="1"/>
           <p:nvPr/>
         </p:nvSpPr>
         <p:spPr>
           <a:xfrm>
-            <a:off x="720000" y="1548000"/>
-            <a:ext cx="3224039" cy="540000"/>
+            <a:off x="324000" y="244800"/>
+            <a:ext cx="1080000" cy="251999"/>
           </a:xfrm>
           <a:prstGeom prst="rect">
             <a:avLst/>
@@ -7762,29 +7768,29 @@
           </a:bodyPr>
           <a:lstStyle/>
           <a:p>
-            <a:pPr algn="l"/>
-            <a:r>
-              <a:rPr sz="1700" b="1" i="0">
+            <a:pPr algn="ctr"/>
+            <a:r>
+              <a:rPr sz="1200" b="1" i="0">
                 <a:solidFill>
-                  <a:srgbClr val="1F4E79"/>
+                  <a:srgbClr val="FFFFFF"/>
                 </a:solidFill>
                 <a:latin typeface="Calibri"/>
               </a:rPr>
-              <a:t>Bez kont, bez instalacji</a:t>
-            </a:r>
-          </a:p>
-        </p:txBody>
-      </p:sp>
-      <p:sp>
-        <p:nvSpPr>
-          <p:cNvPr id="9" name="TextBox 8"/>
+              <a:t>KROK 13</a:t>
+            </a:r>
+          </a:p>
+        </p:txBody>
+      </p:sp>
+      <p:sp>
+        <p:nvSpPr>
+          <p:cNvPr id="6" name="TextBox 5"/>
           <p:cNvSpPr txBox="1"/>
           <p:nvPr/>
         </p:nvSpPr>
         <p:spPr>
           <a:xfrm>
-            <a:off x="720000" y="2160000"/>
-            <a:ext cx="3224039" cy="1368000"/>
+            <a:off x="1548000" y="198000"/>
+            <a:ext cx="10032119" cy="432000"/>
           </a:xfrm>
           <a:prstGeom prst="rect">
             <a:avLst/>
@@ -7799,803 +7805,151 @@
           <a:p>
             <a:pPr algn="l"/>
             <a:r>
-              <a:rPr sz="1300" b="0" i="0">
+              <a:rPr sz="2200" b="1" i="0">
+                <a:solidFill>
+                  <a:srgbClr val="FFFFFF"/>
+                </a:solidFill>
+                <a:latin typeface="Calibri"/>
+              </a:rPr>
+              <a:t>Prowadzący widzi sesję na żywo</a:t>
+            </a:r>
+          </a:p>
+        </p:txBody>
+      </p:sp>
+      <p:sp>
+        <p:nvSpPr>
+          <p:cNvPr id="7" name="TextBox 6"/>
+          <p:cNvSpPr txBox="1"/>
+          <p:nvPr/>
+        </p:nvSpPr>
+        <p:spPr>
+          <a:xfrm>
+            <a:off x="11112119" y="270000"/>
+            <a:ext cx="900000" cy="216000"/>
+          </a:xfrm>
+          <a:prstGeom prst="rect">
+            <a:avLst/>
+          </a:prstGeom>
+          <a:noFill/>
+        </p:spPr>
+        <p:txBody>
+          <a:bodyPr wrap="square" lIns="0" rIns="0" tIns="0" bIns="0">
+            <a:spAutoFit/>
+          </a:bodyPr>
+          <a:lstStyle/>
+          <a:p>
+            <a:pPr algn="r"/>
+            <a:r>
+              <a:rPr sz="1000" b="0" i="0">
+                <a:solidFill>
+                  <a:srgbClr val="E8F0F9"/>
+                </a:solidFill>
+                <a:latin typeface="Calibri"/>
+              </a:rPr>
+              <a:t>20 / 23</a:t>
+            </a:r>
+          </a:p>
+        </p:txBody>
+      </p:sp>
+      <p:sp>
+        <p:nvSpPr>
+          <p:cNvPr id="8" name="Rectangle 7"/>
+          <p:cNvSpPr/>
+          <p:nvPr/>
+        </p:nvSpPr>
+        <p:spPr>
+          <a:xfrm>
+            <a:off x="2251259" y="1015200"/>
+            <a:ext cx="7776000" cy="4860000"/>
+          </a:xfrm>
+          <a:prstGeom prst="rect">
+            <a:avLst/>
+          </a:prstGeom>
+          <a:solidFill>
+            <a:srgbClr val="D8D8D8"/>
+          </a:solidFill>
+          <a:ln>
+            <a:noFill/>
+          </a:ln>
+          <a:effectLst/>
+        </p:spPr>
+        <p:style>
+          <a:lnRef idx="1">
+            <a:schemeClr val="accent1"/>
+          </a:lnRef>
+          <a:fillRef idx="3">
+            <a:schemeClr val="accent1"/>
+          </a:fillRef>
+          <a:effectRef idx="2">
+            <a:schemeClr val="accent1"/>
+          </a:effectRef>
+          <a:fontRef idx="minor">
+            <a:schemeClr val="lt1"/>
+          </a:fontRef>
+        </p:style>
+        <p:txBody>
+          <a:bodyPr rtlCol="0" anchor="ctr"/>
+          <a:lstStyle/>
+          <a:p>
+            <a:pPr algn="ctr"/>
+          </a:p>
+        </p:txBody>
+      </p:sp>
+      <p:pic>
+        <p:nvPicPr>
+          <p:cNvPr id="9" name="Picture 8" descr="admin-running.png"/>
+          <p:cNvPicPr>
+            <a:picLocks noChangeAspect="1"/>
+          </p:cNvPicPr>
+          <p:nvPr/>
+        </p:nvPicPr>
+        <p:blipFill>
+          <a:blip r:embed="rId2"/>
+          <a:stretch>
+            <a:fillRect/>
+          </a:stretch>
+        </p:blipFill>
+        <p:spPr>
+          <a:xfrm>
+            <a:off x="2208059" y="972000"/>
+            <a:ext cx="7776000" cy="4860000"/>
+          </a:xfrm>
+          <a:prstGeom prst="rect">
+            <a:avLst/>
+          </a:prstGeom>
+        </p:spPr>
+      </p:pic>
+      <p:sp>
+        <p:nvSpPr>
+          <p:cNvPr id="10" name="TextBox 9"/>
+          <p:cNvSpPr txBox="1"/>
+          <p:nvPr/>
+        </p:nvSpPr>
+        <p:spPr>
+          <a:xfrm>
+            <a:off x="432000" y="5976000"/>
+            <a:ext cx="11328119" cy="720000"/>
+          </a:xfrm>
+          <a:prstGeom prst="rect">
+            <a:avLst/>
+          </a:prstGeom>
+          <a:noFill/>
+        </p:spPr>
+        <p:txBody>
+          <a:bodyPr wrap="square" lIns="0" rIns="0" tIns="0" bIns="0">
+            <a:spAutoFit/>
+          </a:bodyPr>
+          <a:lstStyle/>
+          <a:p>
+            <a:pPr algn="ctr"/>
+            <a:r>
+              <a:rPr sz="1800" b="0" i="0">
                 <a:solidFill>
                   <a:srgbClr val="1A1A1A"/>
                 </a:solidFill>
                 <a:latin typeface="Calibri"/>
               </a:rPr>
-              <a:t>Uczestnik skanuje kod, wpisuje pseudonim, gra. To wszystko.</a:t>
-            </a:r>
-          </a:p>
-        </p:txBody>
-      </p:sp>
-      <p:sp>
-        <p:nvSpPr>
-          <p:cNvPr id="10" name="Rounded Rectangle 9"/>
-          <p:cNvSpPr/>
-          <p:nvPr/>
-        </p:nvSpPr>
-        <p:spPr>
-          <a:xfrm>
-            <a:off x="4304039" y="1260000"/>
-            <a:ext cx="3584039" cy="2340000"/>
-          </a:xfrm>
-          <a:prstGeom prst="roundRect">
-            <a:avLst/>
-          </a:prstGeom>
-          <a:solidFill>
-            <a:srgbClr val="E8F0F9"/>
-          </a:solidFill>
-          <a:ln>
-            <a:noFill/>
-          </a:ln>
-          <a:effectLst/>
-        </p:spPr>
-        <p:style>
-          <a:lnRef idx="1">
-            <a:schemeClr val="accent1"/>
-          </a:lnRef>
-          <a:fillRef idx="3">
-            <a:schemeClr val="accent1"/>
-          </a:fillRef>
-          <a:effectRef idx="2">
-            <a:schemeClr val="accent1"/>
-          </a:effectRef>
-          <a:fontRef idx="minor">
-            <a:schemeClr val="lt1"/>
-          </a:fontRef>
-        </p:style>
-        <p:txBody>
-          <a:bodyPr rtlCol="0" anchor="ctr"/>
-          <a:lstStyle/>
-          <a:p>
-            <a:pPr algn="ctr"/>
-          </a:p>
-        </p:txBody>
-      </p:sp>
-      <p:sp>
-        <p:nvSpPr>
-          <p:cNvPr id="11" name="Rectangle 10"/>
-          <p:cNvSpPr/>
-          <p:nvPr/>
-        </p:nvSpPr>
-        <p:spPr>
-          <a:xfrm>
-            <a:off x="4304039" y="1260000"/>
-            <a:ext cx="3584039" cy="125999"/>
-          </a:xfrm>
-          <a:prstGeom prst="rect">
-            <a:avLst/>
-          </a:prstGeom>
-          <a:solidFill>
-            <a:srgbClr val="E8B44F"/>
-          </a:solidFill>
-          <a:ln>
-            <a:noFill/>
-          </a:ln>
-          <a:effectLst/>
-        </p:spPr>
-        <p:style>
-          <a:lnRef idx="1">
-            <a:schemeClr val="accent1"/>
-          </a:lnRef>
-          <a:fillRef idx="3">
-            <a:schemeClr val="accent1"/>
-          </a:fillRef>
-          <a:effectRef idx="2">
-            <a:schemeClr val="accent1"/>
-          </a:effectRef>
-          <a:fontRef idx="minor">
-            <a:schemeClr val="lt1"/>
-          </a:fontRef>
-        </p:style>
-        <p:txBody>
-          <a:bodyPr rtlCol="0" anchor="ctr"/>
-          <a:lstStyle/>
-          <a:p>
-            <a:pPr algn="ctr"/>
-          </a:p>
-        </p:txBody>
-      </p:sp>
-      <p:sp>
-        <p:nvSpPr>
-          <p:cNvPr id="12" name="TextBox 11"/>
-          <p:cNvSpPr txBox="1"/>
-          <p:nvPr/>
-        </p:nvSpPr>
-        <p:spPr>
-          <a:xfrm>
-            <a:off x="4484039" y="1548000"/>
-            <a:ext cx="3224039" cy="540000"/>
-          </a:xfrm>
-          <a:prstGeom prst="rect">
-            <a:avLst/>
-          </a:prstGeom>
-          <a:noFill/>
-        </p:spPr>
-        <p:txBody>
-          <a:bodyPr wrap="square" lIns="0" rIns="0" tIns="0" bIns="0">
-            <a:spAutoFit/>
-          </a:bodyPr>
-          <a:lstStyle/>
-          <a:p>
-            <a:pPr algn="l"/>
-            <a:r>
-              <a:rPr sz="1700" b="1" i="0">
-                <a:solidFill>
-                  <a:srgbClr val="1F4E79"/>
-                </a:solidFill>
-                <a:latin typeface="Calibri"/>
-              </a:rPr>
-              <a:t>Lekka i szybka</a:t>
-            </a:r>
-          </a:p>
-        </p:txBody>
-      </p:sp>
-      <p:sp>
-        <p:nvSpPr>
-          <p:cNvPr id="13" name="TextBox 12"/>
-          <p:cNvSpPr txBox="1"/>
-          <p:nvPr/>
-        </p:nvSpPr>
-        <p:spPr>
-          <a:xfrm>
-            <a:off x="4484039" y="2160000"/>
-            <a:ext cx="3224039" cy="1368000"/>
-          </a:xfrm>
-          <a:prstGeom prst="rect">
-            <a:avLst/>
-          </a:prstGeom>
-          <a:noFill/>
-        </p:spPr>
-        <p:txBody>
-          <a:bodyPr wrap="square" lIns="0" rIns="0" tIns="0" bIns="0">
-            <a:spAutoFit/>
-          </a:bodyPr>
-          <a:lstStyle/>
-          <a:p>
-            <a:pPr algn="l"/>
-            <a:r>
-              <a:rPr sz="1300" b="0" i="0">
-                <a:solidFill>
-                  <a:srgbClr val="1A1A1A"/>
-                </a:solidFill>
-                <a:latin typeface="Calibri"/>
-              </a:rPr>
-              <a:t>Działa w zwykłej przeglądarce — nawet słabszy telefon wystarczy.</a:t>
-            </a:r>
-          </a:p>
-        </p:txBody>
-      </p:sp>
-      <p:sp>
-        <p:nvSpPr>
-          <p:cNvPr id="14" name="Rounded Rectangle 13"/>
-          <p:cNvSpPr/>
-          <p:nvPr/>
-        </p:nvSpPr>
-        <p:spPr>
-          <a:xfrm>
-            <a:off x="8068079" y="1260000"/>
-            <a:ext cx="3584039" cy="2340000"/>
-          </a:xfrm>
-          <a:prstGeom prst="roundRect">
-            <a:avLst/>
-          </a:prstGeom>
-          <a:solidFill>
-            <a:srgbClr val="E8F0F9"/>
-          </a:solidFill>
-          <a:ln>
-            <a:noFill/>
-          </a:ln>
-          <a:effectLst/>
-        </p:spPr>
-        <p:style>
-          <a:lnRef idx="1">
-            <a:schemeClr val="accent1"/>
-          </a:lnRef>
-          <a:fillRef idx="3">
-            <a:schemeClr val="accent1"/>
-          </a:fillRef>
-          <a:effectRef idx="2">
-            <a:schemeClr val="accent1"/>
-          </a:effectRef>
-          <a:fontRef idx="minor">
-            <a:schemeClr val="lt1"/>
-          </a:fontRef>
-        </p:style>
-        <p:txBody>
-          <a:bodyPr rtlCol="0" anchor="ctr"/>
-          <a:lstStyle/>
-          <a:p>
-            <a:pPr algn="ctr"/>
-          </a:p>
-        </p:txBody>
-      </p:sp>
-      <p:sp>
-        <p:nvSpPr>
-          <p:cNvPr id="15" name="Rectangle 14"/>
-          <p:cNvSpPr/>
-          <p:nvPr/>
-        </p:nvSpPr>
-        <p:spPr>
-          <a:xfrm>
-            <a:off x="8068079" y="1260000"/>
-            <a:ext cx="3584039" cy="125999"/>
-          </a:xfrm>
-          <a:prstGeom prst="rect">
-            <a:avLst/>
-          </a:prstGeom>
-          <a:solidFill>
-            <a:srgbClr val="E8B44F"/>
-          </a:solidFill>
-          <a:ln>
-            <a:noFill/>
-          </a:ln>
-          <a:effectLst/>
-        </p:spPr>
-        <p:style>
-          <a:lnRef idx="1">
-            <a:schemeClr val="accent1"/>
-          </a:lnRef>
-          <a:fillRef idx="3">
-            <a:schemeClr val="accent1"/>
-          </a:fillRef>
-          <a:effectRef idx="2">
-            <a:schemeClr val="accent1"/>
-          </a:effectRef>
-          <a:fontRef idx="minor">
-            <a:schemeClr val="lt1"/>
-          </a:fontRef>
-        </p:style>
-        <p:txBody>
-          <a:bodyPr rtlCol="0" anchor="ctr"/>
-          <a:lstStyle/>
-          <a:p>
-            <a:pPr algn="ctr"/>
-          </a:p>
-        </p:txBody>
-      </p:sp>
-      <p:sp>
-        <p:nvSpPr>
-          <p:cNvPr id="16" name="TextBox 15"/>
-          <p:cNvSpPr txBox="1"/>
-          <p:nvPr/>
-        </p:nvSpPr>
-        <p:spPr>
-          <a:xfrm>
-            <a:off x="8248079" y="1548000"/>
-            <a:ext cx="3224039" cy="540000"/>
-          </a:xfrm>
-          <a:prstGeom prst="rect">
-            <a:avLst/>
-          </a:prstGeom>
-          <a:noFill/>
-        </p:spPr>
-        <p:txBody>
-          <a:bodyPr wrap="square" lIns="0" rIns="0" tIns="0" bIns="0">
-            <a:spAutoFit/>
-          </a:bodyPr>
-          <a:lstStyle/>
-          <a:p>
-            <a:pPr algn="l"/>
-            <a:r>
-              <a:rPr sz="1700" b="1" i="0">
-                <a:solidFill>
-                  <a:srgbClr val="1F4E79"/>
-                </a:solidFill>
-                <a:latin typeface="Calibri"/>
-              </a:rPr>
-              <a:t>Dla dużej sali</a:t>
-            </a:r>
-          </a:p>
-        </p:txBody>
-      </p:sp>
-      <p:sp>
-        <p:nvSpPr>
-          <p:cNvPr id="17" name="TextBox 16"/>
-          <p:cNvSpPr txBox="1"/>
-          <p:nvPr/>
-        </p:nvSpPr>
-        <p:spPr>
-          <a:xfrm>
-            <a:off x="8248079" y="2160000"/>
-            <a:ext cx="3224039" cy="1368000"/>
-          </a:xfrm>
-          <a:prstGeom prst="rect">
-            <a:avLst/>
-          </a:prstGeom>
-          <a:noFill/>
-        </p:spPr>
-        <p:txBody>
-          <a:bodyPr wrap="square" lIns="0" rIns="0" tIns="0" bIns="0">
-            <a:spAutoFit/>
-          </a:bodyPr>
-          <a:lstStyle/>
-          <a:p>
-            <a:pPr algn="l"/>
-            <a:r>
-              <a:rPr sz="1300" b="0" i="0">
-                <a:solidFill>
-                  <a:srgbClr val="1A1A1A"/>
-                </a:solidFill>
-                <a:latin typeface="Calibri"/>
-              </a:rPr>
-              <a:t>Od kilku do kilkuset uczestników jednocześnie, bez limitów.</a:t>
-            </a:r>
-          </a:p>
-        </p:txBody>
-      </p:sp>
-      <p:sp>
-        <p:nvSpPr>
-          <p:cNvPr id="18" name="Rounded Rectangle 17"/>
-          <p:cNvSpPr/>
-          <p:nvPr/>
-        </p:nvSpPr>
-        <p:spPr>
-          <a:xfrm>
-            <a:off x="540000" y="3816000"/>
-            <a:ext cx="3584039" cy="2340000"/>
-          </a:xfrm>
-          <a:prstGeom prst="roundRect">
-            <a:avLst/>
-          </a:prstGeom>
-          <a:solidFill>
-            <a:srgbClr val="E8F0F9"/>
-          </a:solidFill>
-          <a:ln>
-            <a:noFill/>
-          </a:ln>
-          <a:effectLst/>
-        </p:spPr>
-        <p:style>
-          <a:lnRef idx="1">
-            <a:schemeClr val="accent1"/>
-          </a:lnRef>
-          <a:fillRef idx="3">
-            <a:schemeClr val="accent1"/>
-          </a:fillRef>
-          <a:effectRef idx="2">
-            <a:schemeClr val="accent1"/>
-          </a:effectRef>
-          <a:fontRef idx="minor">
-            <a:schemeClr val="lt1"/>
-          </a:fontRef>
-        </p:style>
-        <p:txBody>
-          <a:bodyPr rtlCol="0" anchor="ctr"/>
-          <a:lstStyle/>
-          <a:p>
-            <a:pPr algn="ctr"/>
-          </a:p>
-        </p:txBody>
-      </p:sp>
-      <p:sp>
-        <p:nvSpPr>
-          <p:cNvPr id="19" name="Rectangle 18"/>
-          <p:cNvSpPr/>
-          <p:nvPr/>
-        </p:nvSpPr>
-        <p:spPr>
-          <a:xfrm>
-            <a:off x="540000" y="3816000"/>
-            <a:ext cx="3584039" cy="125999"/>
-          </a:xfrm>
-          <a:prstGeom prst="rect">
-            <a:avLst/>
-          </a:prstGeom>
-          <a:solidFill>
-            <a:srgbClr val="E8B44F"/>
-          </a:solidFill>
-          <a:ln>
-            <a:noFill/>
-          </a:ln>
-          <a:effectLst/>
-        </p:spPr>
-        <p:style>
-          <a:lnRef idx="1">
-            <a:schemeClr val="accent1"/>
-          </a:lnRef>
-          <a:fillRef idx="3">
-            <a:schemeClr val="accent1"/>
-          </a:fillRef>
-          <a:effectRef idx="2">
-            <a:schemeClr val="accent1"/>
-          </a:effectRef>
-          <a:fontRef idx="minor">
-            <a:schemeClr val="lt1"/>
-          </a:fontRef>
-        </p:style>
-        <p:txBody>
-          <a:bodyPr rtlCol="0" anchor="ctr"/>
-          <a:lstStyle/>
-          <a:p>
-            <a:pPr algn="ctr"/>
-          </a:p>
-        </p:txBody>
-      </p:sp>
-      <p:sp>
-        <p:nvSpPr>
-          <p:cNvPr id="20" name="TextBox 19"/>
-          <p:cNvSpPr txBox="1"/>
-          <p:nvPr/>
-        </p:nvSpPr>
-        <p:spPr>
-          <a:xfrm>
-            <a:off x="720000" y="4104000"/>
-            <a:ext cx="3224039" cy="540000"/>
-          </a:xfrm>
-          <a:prstGeom prst="rect">
-            <a:avLst/>
-          </a:prstGeom>
-          <a:noFill/>
-        </p:spPr>
-        <p:txBody>
-          <a:bodyPr wrap="square" lIns="0" rIns="0" tIns="0" bIns="0">
-            <a:spAutoFit/>
-          </a:bodyPr>
-          <a:lstStyle/>
-          <a:p>
-            <a:pPr algn="l"/>
-            <a:r>
-              <a:rPr sz="1700" b="1" i="0">
-                <a:solidFill>
-                  <a:srgbClr val="1F4E79"/>
-                </a:solidFill>
-                <a:latin typeface="Calibri"/>
-              </a:rPr>
-              <a:t>Wasze dane zostają u Was</a:t>
-            </a:r>
-          </a:p>
-        </p:txBody>
-      </p:sp>
-      <p:sp>
-        <p:nvSpPr>
-          <p:cNvPr id="21" name="TextBox 20"/>
-          <p:cNvSpPr txBox="1"/>
-          <p:nvPr/>
-        </p:nvSpPr>
-        <p:spPr>
-          <a:xfrm>
-            <a:off x="720000" y="4716000"/>
-            <a:ext cx="3224039" cy="1368000"/>
-          </a:xfrm>
-          <a:prstGeom prst="rect">
-            <a:avLst/>
-          </a:prstGeom>
-          <a:noFill/>
-        </p:spPr>
-        <p:txBody>
-          <a:bodyPr wrap="square" lIns="0" rIns="0" tIns="0" bIns="0">
-            <a:spAutoFit/>
-          </a:bodyPr>
-          <a:lstStyle/>
-          <a:p>
-            <a:pPr algn="l"/>
-            <a:r>
-              <a:rPr sz="1300" b="0" i="0">
-                <a:solidFill>
-                  <a:srgbClr val="1A1A1A"/>
-                </a:solidFill>
-                <a:latin typeface="Calibri"/>
-              </a:rPr>
-              <a:t>Quizy i wyniki nie wędrują do żadnej obcej chmury.</a:t>
-            </a:r>
-          </a:p>
-        </p:txBody>
-      </p:sp>
-      <p:sp>
-        <p:nvSpPr>
-          <p:cNvPr id="22" name="Rounded Rectangle 21"/>
-          <p:cNvSpPr/>
-          <p:nvPr/>
-        </p:nvSpPr>
-        <p:spPr>
-          <a:xfrm>
-            <a:off x="4304039" y="3816000"/>
-            <a:ext cx="3584039" cy="2340000"/>
-          </a:xfrm>
-          <a:prstGeom prst="roundRect">
-            <a:avLst/>
-          </a:prstGeom>
-          <a:solidFill>
-            <a:srgbClr val="E8F0F9"/>
-          </a:solidFill>
-          <a:ln>
-            <a:noFill/>
-          </a:ln>
-          <a:effectLst/>
-        </p:spPr>
-        <p:style>
-          <a:lnRef idx="1">
-            <a:schemeClr val="accent1"/>
-          </a:lnRef>
-          <a:fillRef idx="3">
-            <a:schemeClr val="accent1"/>
-          </a:fillRef>
-          <a:effectRef idx="2">
-            <a:schemeClr val="accent1"/>
-          </a:effectRef>
-          <a:fontRef idx="minor">
-            <a:schemeClr val="lt1"/>
-          </a:fontRef>
-        </p:style>
-        <p:txBody>
-          <a:bodyPr rtlCol="0" anchor="ctr"/>
-          <a:lstStyle/>
-          <a:p>
-            <a:pPr algn="ctr"/>
-          </a:p>
-        </p:txBody>
-      </p:sp>
-      <p:sp>
-        <p:nvSpPr>
-          <p:cNvPr id="23" name="Rectangle 22"/>
-          <p:cNvSpPr/>
-          <p:nvPr/>
-        </p:nvSpPr>
-        <p:spPr>
-          <a:xfrm>
-            <a:off x="4304039" y="3816000"/>
-            <a:ext cx="3584039" cy="125999"/>
-          </a:xfrm>
-          <a:prstGeom prst="rect">
-            <a:avLst/>
-          </a:prstGeom>
-          <a:solidFill>
-            <a:srgbClr val="E8B44F"/>
-          </a:solidFill>
-          <a:ln>
-            <a:noFill/>
-          </a:ln>
-          <a:effectLst/>
-        </p:spPr>
-        <p:style>
-          <a:lnRef idx="1">
-            <a:schemeClr val="accent1"/>
-          </a:lnRef>
-          <a:fillRef idx="3">
-            <a:schemeClr val="accent1"/>
-          </a:fillRef>
-          <a:effectRef idx="2">
-            <a:schemeClr val="accent1"/>
-          </a:effectRef>
-          <a:fontRef idx="minor">
-            <a:schemeClr val="lt1"/>
-          </a:fontRef>
-        </p:style>
-        <p:txBody>
-          <a:bodyPr rtlCol="0" anchor="ctr"/>
-          <a:lstStyle/>
-          <a:p>
-            <a:pPr algn="ctr"/>
-          </a:p>
-        </p:txBody>
-      </p:sp>
-      <p:sp>
-        <p:nvSpPr>
-          <p:cNvPr id="24" name="TextBox 23"/>
-          <p:cNvSpPr txBox="1"/>
-          <p:nvPr/>
-        </p:nvSpPr>
-        <p:spPr>
-          <a:xfrm>
-            <a:off x="4484039" y="4104000"/>
-            <a:ext cx="3224039" cy="540000"/>
-          </a:xfrm>
-          <a:prstGeom prst="rect">
-            <a:avLst/>
-          </a:prstGeom>
-          <a:noFill/>
-        </p:spPr>
-        <p:txBody>
-          <a:bodyPr wrap="square" lIns="0" rIns="0" tIns="0" bIns="0">
-            <a:spAutoFit/>
-          </a:bodyPr>
-          <a:lstStyle/>
-          <a:p>
-            <a:pPr algn="l"/>
-            <a:r>
-              <a:rPr sz="1700" b="1" i="0">
-                <a:solidFill>
-                  <a:srgbClr val="1F4E79"/>
-                </a:solidFill>
-                <a:latin typeface="Calibri"/>
-              </a:rPr>
-              <a:t>Pełna kontrola w trakcie</a:t>
-            </a:r>
-          </a:p>
-        </p:txBody>
-      </p:sp>
-      <p:sp>
-        <p:nvSpPr>
-          <p:cNvPr id="25" name="TextBox 24"/>
-          <p:cNvSpPr txBox="1"/>
-          <p:nvPr/>
-        </p:nvSpPr>
-        <p:spPr>
-          <a:xfrm>
-            <a:off x="4484039" y="4716000"/>
-            <a:ext cx="3224039" cy="1368000"/>
-          </a:xfrm>
-          <a:prstGeom prst="rect">
-            <a:avLst/>
-          </a:prstGeom>
-          <a:noFill/>
-        </p:spPr>
-        <p:txBody>
-          <a:bodyPr wrap="square" lIns="0" rIns="0" tIns="0" bIns="0">
-            <a:spAutoFit/>
-          </a:bodyPr>
-          <a:lstStyle/>
-          <a:p>
-            <a:pPr algn="l"/>
-            <a:r>
-              <a:rPr sz="1300" b="0" i="0">
-                <a:solidFill>
-                  <a:srgbClr val="1A1A1A"/>
-                </a:solidFill>
-                <a:latin typeface="Calibri"/>
-              </a:rPr>
-              <a:t>Widzicie kto dołączył, kto odpowiedział, możecie zablokować lub zakończyć.</a:t>
-            </a:r>
-          </a:p>
-        </p:txBody>
-      </p:sp>
-      <p:sp>
-        <p:nvSpPr>
-          <p:cNvPr id="26" name="Rounded Rectangle 25"/>
-          <p:cNvSpPr/>
-          <p:nvPr/>
-        </p:nvSpPr>
-        <p:spPr>
-          <a:xfrm>
-            <a:off x="8068079" y="3816000"/>
-            <a:ext cx="3584039" cy="2340000"/>
-          </a:xfrm>
-          <a:prstGeom prst="roundRect">
-            <a:avLst/>
-          </a:prstGeom>
-          <a:solidFill>
-            <a:srgbClr val="E8F0F9"/>
-          </a:solidFill>
-          <a:ln>
-            <a:noFill/>
-          </a:ln>
-          <a:effectLst/>
-        </p:spPr>
-        <p:style>
-          <a:lnRef idx="1">
-            <a:schemeClr val="accent1"/>
-          </a:lnRef>
-          <a:fillRef idx="3">
-            <a:schemeClr val="accent1"/>
-          </a:fillRef>
-          <a:effectRef idx="2">
-            <a:schemeClr val="accent1"/>
-          </a:effectRef>
-          <a:fontRef idx="minor">
-            <a:schemeClr val="lt1"/>
-          </a:fontRef>
-        </p:style>
-        <p:txBody>
-          <a:bodyPr rtlCol="0" anchor="ctr"/>
-          <a:lstStyle/>
-          <a:p>
-            <a:pPr algn="ctr"/>
-          </a:p>
-        </p:txBody>
-      </p:sp>
-      <p:sp>
-        <p:nvSpPr>
-          <p:cNvPr id="27" name="Rectangle 26"/>
-          <p:cNvSpPr/>
-          <p:nvPr/>
-        </p:nvSpPr>
-        <p:spPr>
-          <a:xfrm>
-            <a:off x="8068079" y="3816000"/>
-            <a:ext cx="3584039" cy="125999"/>
-          </a:xfrm>
-          <a:prstGeom prst="rect">
-            <a:avLst/>
-          </a:prstGeom>
-          <a:solidFill>
-            <a:srgbClr val="E8B44F"/>
-          </a:solidFill>
-          <a:ln>
-            <a:noFill/>
-          </a:ln>
-          <a:effectLst/>
-        </p:spPr>
-        <p:style>
-          <a:lnRef idx="1">
-            <a:schemeClr val="accent1"/>
-          </a:lnRef>
-          <a:fillRef idx="3">
-            <a:schemeClr val="accent1"/>
-          </a:fillRef>
-          <a:effectRef idx="2">
-            <a:schemeClr val="accent1"/>
-          </a:effectRef>
-          <a:fontRef idx="minor">
-            <a:schemeClr val="lt1"/>
-          </a:fontRef>
-        </p:style>
-        <p:txBody>
-          <a:bodyPr rtlCol="0" anchor="ctr"/>
-          <a:lstStyle/>
-          <a:p>
-            <a:pPr algn="ctr"/>
-          </a:p>
-        </p:txBody>
-      </p:sp>
-      <p:sp>
-        <p:nvSpPr>
-          <p:cNvPr id="28" name="TextBox 27"/>
-          <p:cNvSpPr txBox="1"/>
-          <p:nvPr/>
-        </p:nvSpPr>
-        <p:spPr>
-          <a:xfrm>
-            <a:off x="8248079" y="4104000"/>
-            <a:ext cx="3224039" cy="540000"/>
-          </a:xfrm>
-          <a:prstGeom prst="rect">
-            <a:avLst/>
-          </a:prstGeom>
-          <a:noFill/>
-        </p:spPr>
-        <p:txBody>
-          <a:bodyPr wrap="square" lIns="0" rIns="0" tIns="0" bIns="0">
-            <a:spAutoFit/>
-          </a:bodyPr>
-          <a:lstStyle/>
-          <a:p>
-            <a:pPr algn="l"/>
-            <a:r>
-              <a:rPr sz="1700" b="1" i="0">
-                <a:solidFill>
-                  <a:srgbClr val="1F4E79"/>
-                </a:solidFill>
-                <a:latin typeface="Calibri"/>
-              </a:rPr>
-              <a:t>Łatwe przenoszenie</a:t>
-            </a:r>
-          </a:p>
-        </p:txBody>
-      </p:sp>
-      <p:sp>
-        <p:nvSpPr>
-          <p:cNvPr id="29" name="TextBox 28"/>
-          <p:cNvSpPr txBox="1"/>
-          <p:nvPr/>
-        </p:nvSpPr>
-        <p:spPr>
-          <a:xfrm>
-            <a:off x="8248079" y="4716000"/>
-            <a:ext cx="3224039" cy="1368000"/>
-          </a:xfrm>
-          <a:prstGeom prst="rect">
-            <a:avLst/>
-          </a:prstGeom>
-          <a:noFill/>
-        </p:spPr>
-        <p:txBody>
-          <a:bodyPr wrap="square" lIns="0" rIns="0" tIns="0" bIns="0">
-            <a:spAutoFit/>
-          </a:bodyPr>
-          <a:lstStyle/>
-          <a:p>
-            <a:pPr algn="l"/>
-            <a:r>
-              <a:rPr sz="1300" b="0" i="0">
-                <a:solidFill>
-                  <a:srgbClr val="1A1A1A"/>
-                </a:solidFill>
-                <a:latin typeface="Calibri"/>
-              </a:rPr>
-              <a:t>Cały quiz w jednym pliku — między komputerami, między prowadzącymi.</a:t>
+              <a:t>Lista uczestników aktualizuje się w czasie rzeczywistym - kto dołączył, kto odpowiedział, jakie ma punkty.</a:t>
             </a:r>
           </a:p>
         </p:txBody>
@@ -8609,6 +7963,1504 @@
 </file>
 
 <file path=ppt/slides/slide21.xml><?xml version="1.0" encoding="utf-8"?>
+<p:sld xmlns:a="http://schemas.openxmlformats.org/drawingml/2006/main" xmlns:p="http://schemas.openxmlformats.org/presentationml/2006/main" xmlns:r="http://schemas.openxmlformats.org/officeDocument/2006/relationships">
+  <p:cSld>
+    <p:bg>
+      <p:bgPr>
+        <a:solidFill>
+          <a:srgbClr val="FFFFFF"/>
+        </a:solidFill>
+        <a:effectLst/>
+      </p:bgPr>
+    </p:bg>
+    <p:spTree>
+      <p:nvGrpSpPr>
+        <p:cNvPr id="1" name=""/>
+        <p:cNvGrpSpPr/>
+        <p:nvPr/>
+      </p:nvGrpSpPr>
+      <p:grpSpPr/>
+      <p:sp>
+        <p:nvSpPr>
+          <p:cNvPr id="2" name="Rectangle 1"/>
+          <p:cNvSpPr/>
+          <p:nvPr/>
+        </p:nvSpPr>
+        <p:spPr>
+          <a:xfrm>
+            <a:off x="0" y="0"/>
+            <a:ext cx="12192119" cy="720000"/>
+          </a:xfrm>
+          <a:prstGeom prst="rect">
+            <a:avLst/>
+          </a:prstGeom>
+          <a:solidFill>
+            <a:srgbClr val="1F4E79"/>
+          </a:solidFill>
+          <a:ln>
+            <a:noFill/>
+          </a:ln>
+          <a:effectLst/>
+        </p:spPr>
+        <p:style>
+          <a:lnRef idx="1">
+            <a:schemeClr val="accent1"/>
+          </a:lnRef>
+          <a:fillRef idx="3">
+            <a:schemeClr val="accent1"/>
+          </a:fillRef>
+          <a:effectRef idx="2">
+            <a:schemeClr val="accent1"/>
+          </a:effectRef>
+          <a:fontRef idx="minor">
+            <a:schemeClr val="lt1"/>
+          </a:fontRef>
+        </p:style>
+        <p:txBody>
+          <a:bodyPr rtlCol="0" anchor="ctr"/>
+          <a:lstStyle/>
+          <a:p>
+            <a:pPr algn="ctr"/>
+          </a:p>
+        </p:txBody>
+      </p:sp>
+      <p:sp>
+        <p:nvSpPr>
+          <p:cNvPr id="3" name="Rectangle 2"/>
+          <p:cNvSpPr/>
+          <p:nvPr/>
+        </p:nvSpPr>
+        <p:spPr>
+          <a:xfrm>
+            <a:off x="0" y="720000"/>
+            <a:ext cx="12192119" cy="36000"/>
+          </a:xfrm>
+          <a:prstGeom prst="rect">
+            <a:avLst/>
+          </a:prstGeom>
+          <a:solidFill>
+            <a:srgbClr val="E8B44F"/>
+          </a:solidFill>
+          <a:ln>
+            <a:noFill/>
+          </a:ln>
+          <a:effectLst/>
+        </p:spPr>
+        <p:style>
+          <a:lnRef idx="1">
+            <a:schemeClr val="accent1"/>
+          </a:lnRef>
+          <a:fillRef idx="3">
+            <a:schemeClr val="accent1"/>
+          </a:fillRef>
+          <a:effectRef idx="2">
+            <a:schemeClr val="accent1"/>
+          </a:effectRef>
+          <a:fontRef idx="minor">
+            <a:schemeClr val="lt1"/>
+          </a:fontRef>
+        </p:style>
+        <p:txBody>
+          <a:bodyPr rtlCol="0" anchor="ctr"/>
+          <a:lstStyle/>
+          <a:p>
+            <a:pPr algn="ctr"/>
+          </a:p>
+        </p:txBody>
+      </p:sp>
+      <p:sp>
+        <p:nvSpPr>
+          <p:cNvPr id="4" name="Rounded Rectangle 3"/>
+          <p:cNvSpPr/>
+          <p:nvPr/>
+        </p:nvSpPr>
+        <p:spPr>
+          <a:xfrm>
+            <a:off x="324000" y="180000"/>
+            <a:ext cx="1080000" cy="360000"/>
+          </a:xfrm>
+          <a:prstGeom prst="roundRect">
+            <a:avLst/>
+          </a:prstGeom>
+          <a:solidFill>
+            <a:srgbClr val="E8B44F"/>
+          </a:solidFill>
+          <a:ln>
+            <a:noFill/>
+          </a:ln>
+          <a:effectLst/>
+        </p:spPr>
+        <p:style>
+          <a:lnRef idx="1">
+            <a:schemeClr val="accent1"/>
+          </a:lnRef>
+          <a:fillRef idx="3">
+            <a:schemeClr val="accent1"/>
+          </a:fillRef>
+          <a:effectRef idx="2">
+            <a:schemeClr val="accent1"/>
+          </a:effectRef>
+          <a:fontRef idx="minor">
+            <a:schemeClr val="lt1"/>
+          </a:fontRef>
+        </p:style>
+        <p:txBody>
+          <a:bodyPr rtlCol="0" anchor="ctr"/>
+          <a:lstStyle/>
+          <a:p>
+            <a:pPr algn="ctr"/>
+          </a:p>
+        </p:txBody>
+      </p:sp>
+      <p:sp>
+        <p:nvSpPr>
+          <p:cNvPr id="5" name="TextBox 4"/>
+          <p:cNvSpPr txBox="1"/>
+          <p:nvPr/>
+        </p:nvSpPr>
+        <p:spPr>
+          <a:xfrm>
+            <a:off x="324000" y="244800"/>
+            <a:ext cx="1080000" cy="251999"/>
+          </a:xfrm>
+          <a:prstGeom prst="rect">
+            <a:avLst/>
+          </a:prstGeom>
+          <a:noFill/>
+        </p:spPr>
+        <p:txBody>
+          <a:bodyPr wrap="square" lIns="0" rIns="0" tIns="0" bIns="0">
+            <a:spAutoFit/>
+          </a:bodyPr>
+          <a:lstStyle/>
+          <a:p>
+            <a:pPr algn="ctr"/>
+            <a:r>
+              <a:rPr sz="1200" b="1" i="0">
+                <a:solidFill>
+                  <a:srgbClr val="FFFFFF"/>
+                </a:solidFill>
+                <a:latin typeface="Calibri"/>
+              </a:rPr>
+              <a:t>KROK 14</a:t>
+            </a:r>
+          </a:p>
+        </p:txBody>
+      </p:sp>
+      <p:sp>
+        <p:nvSpPr>
+          <p:cNvPr id="6" name="TextBox 5"/>
+          <p:cNvSpPr txBox="1"/>
+          <p:nvPr/>
+        </p:nvSpPr>
+        <p:spPr>
+          <a:xfrm>
+            <a:off x="1548000" y="198000"/>
+            <a:ext cx="10032119" cy="432000"/>
+          </a:xfrm>
+          <a:prstGeom prst="rect">
+            <a:avLst/>
+          </a:prstGeom>
+          <a:noFill/>
+        </p:spPr>
+        <p:txBody>
+          <a:bodyPr wrap="square" lIns="0" rIns="0" tIns="0" bIns="0">
+            <a:spAutoFit/>
+          </a:bodyPr>
+          <a:lstStyle/>
+          <a:p>
+            <a:pPr algn="l"/>
+            <a:r>
+              <a:rPr sz="2200" b="1" i="0">
+                <a:solidFill>
+                  <a:srgbClr val="FFFFFF"/>
+                </a:solidFill>
+                <a:latin typeface="Calibri"/>
+              </a:rPr>
+              <a:t>Po zakończeniu - Statystyki</a:t>
+            </a:r>
+          </a:p>
+        </p:txBody>
+      </p:sp>
+      <p:sp>
+        <p:nvSpPr>
+          <p:cNvPr id="7" name="TextBox 6"/>
+          <p:cNvSpPr txBox="1"/>
+          <p:nvPr/>
+        </p:nvSpPr>
+        <p:spPr>
+          <a:xfrm>
+            <a:off x="11112119" y="270000"/>
+            <a:ext cx="900000" cy="216000"/>
+          </a:xfrm>
+          <a:prstGeom prst="rect">
+            <a:avLst/>
+          </a:prstGeom>
+          <a:noFill/>
+        </p:spPr>
+        <p:txBody>
+          <a:bodyPr wrap="square" lIns="0" rIns="0" tIns="0" bIns="0">
+            <a:spAutoFit/>
+          </a:bodyPr>
+          <a:lstStyle/>
+          <a:p>
+            <a:pPr algn="r"/>
+            <a:r>
+              <a:rPr sz="1000" b="0" i="0">
+                <a:solidFill>
+                  <a:srgbClr val="E8F0F9"/>
+                </a:solidFill>
+                <a:latin typeface="Calibri"/>
+              </a:rPr>
+              <a:t>21 / 23</a:t>
+            </a:r>
+          </a:p>
+        </p:txBody>
+      </p:sp>
+      <p:sp>
+        <p:nvSpPr>
+          <p:cNvPr id="8" name="Rectangle 7"/>
+          <p:cNvSpPr/>
+          <p:nvPr/>
+        </p:nvSpPr>
+        <p:spPr>
+          <a:xfrm>
+            <a:off x="2251259" y="1015200"/>
+            <a:ext cx="7776000" cy="4860000"/>
+          </a:xfrm>
+          <a:prstGeom prst="rect">
+            <a:avLst/>
+          </a:prstGeom>
+          <a:solidFill>
+            <a:srgbClr val="D8D8D8"/>
+          </a:solidFill>
+          <a:ln>
+            <a:noFill/>
+          </a:ln>
+          <a:effectLst/>
+        </p:spPr>
+        <p:style>
+          <a:lnRef idx="1">
+            <a:schemeClr val="accent1"/>
+          </a:lnRef>
+          <a:fillRef idx="3">
+            <a:schemeClr val="accent1"/>
+          </a:fillRef>
+          <a:effectRef idx="2">
+            <a:schemeClr val="accent1"/>
+          </a:effectRef>
+          <a:fontRef idx="minor">
+            <a:schemeClr val="lt1"/>
+          </a:fontRef>
+        </p:style>
+        <p:txBody>
+          <a:bodyPr rtlCol="0" anchor="ctr"/>
+          <a:lstStyle/>
+          <a:p>
+            <a:pPr algn="ctr"/>
+          </a:p>
+        </p:txBody>
+      </p:sp>
+      <p:pic>
+        <p:nvPicPr>
+          <p:cNvPr id="9" name="Picture 8" descr="admin-results.png"/>
+          <p:cNvPicPr>
+            <a:picLocks noChangeAspect="1"/>
+          </p:cNvPicPr>
+          <p:nvPr/>
+        </p:nvPicPr>
+        <p:blipFill>
+          <a:blip r:embed="rId2"/>
+          <a:stretch>
+            <a:fillRect/>
+          </a:stretch>
+        </p:blipFill>
+        <p:spPr>
+          <a:xfrm>
+            <a:off x="2208059" y="972000"/>
+            <a:ext cx="7776000" cy="4860000"/>
+          </a:xfrm>
+          <a:prstGeom prst="rect">
+            <a:avLst/>
+          </a:prstGeom>
+        </p:spPr>
+      </p:pic>
+      <p:sp>
+        <p:nvSpPr>
+          <p:cNvPr id="10" name="TextBox 9"/>
+          <p:cNvSpPr txBox="1"/>
+          <p:nvPr/>
+        </p:nvSpPr>
+        <p:spPr>
+          <a:xfrm>
+            <a:off x="432000" y="5976000"/>
+            <a:ext cx="11328119" cy="720000"/>
+          </a:xfrm>
+          <a:prstGeom prst="rect">
+            <a:avLst/>
+          </a:prstGeom>
+          <a:noFill/>
+        </p:spPr>
+        <p:txBody>
+          <a:bodyPr wrap="square" lIns="0" rIns="0" tIns="0" bIns="0">
+            <a:spAutoFit/>
+          </a:bodyPr>
+          <a:lstStyle/>
+          <a:p>
+            <a:pPr algn="ctr"/>
+            <a:r>
+              <a:rPr sz="1800" b="0" i="0">
+                <a:solidFill>
+                  <a:srgbClr val="1A1A1A"/>
+                </a:solidFill>
+                <a:latin typeface="Calibri"/>
+              </a:rPr>
+              <a:t>Każda sesja zapisana w tabeli. Po kliknięciu - szczegóły każdej osoby.</a:t>
+            </a:r>
+          </a:p>
+        </p:txBody>
+      </p:sp>
+    </p:spTree>
+  </p:cSld>
+  <p:clrMapOvr>
+    <a:masterClrMapping/>
+  </p:clrMapOvr>
+</p:sld>
+</file>
+
+<file path=ppt/slides/slide22.xml><?xml version="1.0" encoding="utf-8"?>
+<p:sld xmlns:a="http://schemas.openxmlformats.org/drawingml/2006/main" xmlns:p="http://schemas.openxmlformats.org/presentationml/2006/main" xmlns:r="http://schemas.openxmlformats.org/officeDocument/2006/relationships">
+  <p:cSld>
+    <p:bg>
+      <p:bgPr>
+        <a:solidFill>
+          <a:srgbClr val="FFFFFF"/>
+        </a:solidFill>
+        <a:effectLst/>
+      </p:bgPr>
+    </p:bg>
+    <p:spTree>
+      <p:nvGrpSpPr>
+        <p:cNvPr id="1" name=""/>
+        <p:cNvGrpSpPr/>
+        <p:nvPr/>
+      </p:nvGrpSpPr>
+      <p:grpSpPr/>
+      <p:sp>
+        <p:nvSpPr>
+          <p:cNvPr id="2" name="Rectangle 1"/>
+          <p:cNvSpPr/>
+          <p:nvPr/>
+        </p:nvSpPr>
+        <p:spPr>
+          <a:xfrm>
+            <a:off x="0" y="0"/>
+            <a:ext cx="12192119" cy="720000"/>
+          </a:xfrm>
+          <a:prstGeom prst="rect">
+            <a:avLst/>
+          </a:prstGeom>
+          <a:solidFill>
+            <a:srgbClr val="1F4E79"/>
+          </a:solidFill>
+          <a:ln>
+            <a:noFill/>
+          </a:ln>
+          <a:effectLst/>
+        </p:spPr>
+        <p:style>
+          <a:lnRef idx="1">
+            <a:schemeClr val="accent1"/>
+          </a:lnRef>
+          <a:fillRef idx="3">
+            <a:schemeClr val="accent1"/>
+          </a:fillRef>
+          <a:effectRef idx="2">
+            <a:schemeClr val="accent1"/>
+          </a:effectRef>
+          <a:fontRef idx="minor">
+            <a:schemeClr val="lt1"/>
+          </a:fontRef>
+        </p:style>
+        <p:txBody>
+          <a:bodyPr rtlCol="0" anchor="ctr"/>
+          <a:lstStyle/>
+          <a:p>
+            <a:pPr algn="ctr"/>
+          </a:p>
+        </p:txBody>
+      </p:sp>
+      <p:sp>
+        <p:nvSpPr>
+          <p:cNvPr id="3" name="Rectangle 2"/>
+          <p:cNvSpPr/>
+          <p:nvPr/>
+        </p:nvSpPr>
+        <p:spPr>
+          <a:xfrm>
+            <a:off x="0" y="720000"/>
+            <a:ext cx="12192119" cy="36000"/>
+          </a:xfrm>
+          <a:prstGeom prst="rect">
+            <a:avLst/>
+          </a:prstGeom>
+          <a:solidFill>
+            <a:srgbClr val="E8B44F"/>
+          </a:solidFill>
+          <a:ln>
+            <a:noFill/>
+          </a:ln>
+          <a:effectLst/>
+        </p:spPr>
+        <p:style>
+          <a:lnRef idx="1">
+            <a:schemeClr val="accent1"/>
+          </a:lnRef>
+          <a:fillRef idx="3">
+            <a:schemeClr val="accent1"/>
+          </a:fillRef>
+          <a:effectRef idx="2">
+            <a:schemeClr val="accent1"/>
+          </a:effectRef>
+          <a:fontRef idx="minor">
+            <a:schemeClr val="lt1"/>
+          </a:fontRef>
+        </p:style>
+        <p:txBody>
+          <a:bodyPr rtlCol="0" anchor="ctr"/>
+          <a:lstStyle/>
+          <a:p>
+            <a:pPr algn="ctr"/>
+          </a:p>
+        </p:txBody>
+      </p:sp>
+      <p:sp>
+        <p:nvSpPr>
+          <p:cNvPr id="4" name="TextBox 3"/>
+          <p:cNvSpPr txBox="1"/>
+          <p:nvPr/>
+        </p:nvSpPr>
+        <p:spPr>
+          <a:xfrm>
+            <a:off x="324000" y="198000"/>
+            <a:ext cx="11472119" cy="432000"/>
+          </a:xfrm>
+          <a:prstGeom prst="rect">
+            <a:avLst/>
+          </a:prstGeom>
+          <a:noFill/>
+        </p:spPr>
+        <p:txBody>
+          <a:bodyPr wrap="square" lIns="0" rIns="0" tIns="0" bIns="0">
+            <a:spAutoFit/>
+          </a:bodyPr>
+          <a:lstStyle/>
+          <a:p>
+            <a:pPr algn="l"/>
+            <a:r>
+              <a:rPr sz="2200" b="1" i="0">
+                <a:solidFill>
+                  <a:srgbClr val="FFFFFF"/>
+                </a:solidFill>
+                <a:latin typeface="Calibri"/>
+              </a:rPr>
+              <a:t>Dlaczego Cogniro</a:t>
+            </a:r>
+          </a:p>
+        </p:txBody>
+      </p:sp>
+      <p:sp>
+        <p:nvSpPr>
+          <p:cNvPr id="5" name="TextBox 4"/>
+          <p:cNvSpPr txBox="1"/>
+          <p:nvPr/>
+        </p:nvSpPr>
+        <p:spPr>
+          <a:xfrm>
+            <a:off x="11112119" y="270000"/>
+            <a:ext cx="900000" cy="216000"/>
+          </a:xfrm>
+          <a:prstGeom prst="rect">
+            <a:avLst/>
+          </a:prstGeom>
+          <a:noFill/>
+        </p:spPr>
+        <p:txBody>
+          <a:bodyPr wrap="square" lIns="0" rIns="0" tIns="0" bIns="0">
+            <a:spAutoFit/>
+          </a:bodyPr>
+          <a:lstStyle/>
+          <a:p>
+            <a:pPr algn="r"/>
+            <a:r>
+              <a:rPr sz="1000" b="0" i="0">
+                <a:solidFill>
+                  <a:srgbClr val="E8F0F9"/>
+                </a:solidFill>
+                <a:latin typeface="Calibri"/>
+              </a:rPr>
+              <a:t>22 / 23</a:t>
+            </a:r>
+          </a:p>
+        </p:txBody>
+      </p:sp>
+      <p:sp>
+        <p:nvSpPr>
+          <p:cNvPr id="6" name="Rounded Rectangle 5"/>
+          <p:cNvSpPr/>
+          <p:nvPr/>
+        </p:nvSpPr>
+        <p:spPr>
+          <a:xfrm>
+            <a:off x="540000" y="1260000"/>
+            <a:ext cx="3584039" cy="2340000"/>
+          </a:xfrm>
+          <a:prstGeom prst="roundRect">
+            <a:avLst/>
+          </a:prstGeom>
+          <a:solidFill>
+            <a:srgbClr val="E8F0F9"/>
+          </a:solidFill>
+          <a:ln>
+            <a:noFill/>
+          </a:ln>
+          <a:effectLst/>
+        </p:spPr>
+        <p:style>
+          <a:lnRef idx="1">
+            <a:schemeClr val="accent1"/>
+          </a:lnRef>
+          <a:fillRef idx="3">
+            <a:schemeClr val="accent1"/>
+          </a:fillRef>
+          <a:effectRef idx="2">
+            <a:schemeClr val="accent1"/>
+          </a:effectRef>
+          <a:fontRef idx="minor">
+            <a:schemeClr val="lt1"/>
+          </a:fontRef>
+        </p:style>
+        <p:txBody>
+          <a:bodyPr rtlCol="0" anchor="ctr"/>
+          <a:lstStyle/>
+          <a:p>
+            <a:pPr algn="ctr"/>
+          </a:p>
+        </p:txBody>
+      </p:sp>
+      <p:sp>
+        <p:nvSpPr>
+          <p:cNvPr id="7" name="Rectangle 6"/>
+          <p:cNvSpPr/>
+          <p:nvPr/>
+        </p:nvSpPr>
+        <p:spPr>
+          <a:xfrm>
+            <a:off x="540000" y="1260000"/>
+            <a:ext cx="3584039" cy="125999"/>
+          </a:xfrm>
+          <a:prstGeom prst="rect">
+            <a:avLst/>
+          </a:prstGeom>
+          <a:solidFill>
+            <a:srgbClr val="E8B44F"/>
+          </a:solidFill>
+          <a:ln>
+            <a:noFill/>
+          </a:ln>
+          <a:effectLst/>
+        </p:spPr>
+        <p:style>
+          <a:lnRef idx="1">
+            <a:schemeClr val="accent1"/>
+          </a:lnRef>
+          <a:fillRef idx="3">
+            <a:schemeClr val="accent1"/>
+          </a:fillRef>
+          <a:effectRef idx="2">
+            <a:schemeClr val="accent1"/>
+          </a:effectRef>
+          <a:fontRef idx="minor">
+            <a:schemeClr val="lt1"/>
+          </a:fontRef>
+        </p:style>
+        <p:txBody>
+          <a:bodyPr rtlCol="0" anchor="ctr"/>
+          <a:lstStyle/>
+          <a:p>
+            <a:pPr algn="ctr"/>
+          </a:p>
+        </p:txBody>
+      </p:sp>
+      <p:sp>
+        <p:nvSpPr>
+          <p:cNvPr id="8" name="TextBox 7"/>
+          <p:cNvSpPr txBox="1"/>
+          <p:nvPr/>
+        </p:nvSpPr>
+        <p:spPr>
+          <a:xfrm>
+            <a:off x="720000" y="1548000"/>
+            <a:ext cx="3224039" cy="540000"/>
+          </a:xfrm>
+          <a:prstGeom prst="rect">
+            <a:avLst/>
+          </a:prstGeom>
+          <a:noFill/>
+        </p:spPr>
+        <p:txBody>
+          <a:bodyPr wrap="square" lIns="0" rIns="0" tIns="0" bIns="0">
+            <a:spAutoFit/>
+          </a:bodyPr>
+          <a:lstStyle/>
+          <a:p>
+            <a:pPr algn="l"/>
+            <a:r>
+              <a:rPr sz="1700" b="1" i="0">
+                <a:solidFill>
+                  <a:srgbClr val="1F4E79"/>
+                </a:solidFill>
+                <a:latin typeface="Calibri"/>
+              </a:rPr>
+              <a:t>Bez kont, bez instalacji</a:t>
+            </a:r>
+          </a:p>
+        </p:txBody>
+      </p:sp>
+      <p:sp>
+        <p:nvSpPr>
+          <p:cNvPr id="9" name="TextBox 8"/>
+          <p:cNvSpPr txBox="1"/>
+          <p:nvPr/>
+        </p:nvSpPr>
+        <p:spPr>
+          <a:xfrm>
+            <a:off x="720000" y="2160000"/>
+            <a:ext cx="3224039" cy="1368000"/>
+          </a:xfrm>
+          <a:prstGeom prst="rect">
+            <a:avLst/>
+          </a:prstGeom>
+          <a:noFill/>
+        </p:spPr>
+        <p:txBody>
+          <a:bodyPr wrap="square" lIns="0" rIns="0" tIns="0" bIns="0">
+            <a:spAutoFit/>
+          </a:bodyPr>
+          <a:lstStyle/>
+          <a:p>
+            <a:pPr algn="l"/>
+            <a:r>
+              <a:rPr sz="1300" b="0" i="0">
+                <a:solidFill>
+                  <a:srgbClr val="1A1A1A"/>
+                </a:solidFill>
+                <a:latin typeface="Calibri"/>
+              </a:rPr>
+              <a:t>Uczestnik skanuje kod, wpisuje pseudonim, gra. To wszystko.</a:t>
+            </a:r>
+          </a:p>
+        </p:txBody>
+      </p:sp>
+      <p:sp>
+        <p:nvSpPr>
+          <p:cNvPr id="10" name="Rounded Rectangle 9"/>
+          <p:cNvSpPr/>
+          <p:nvPr/>
+        </p:nvSpPr>
+        <p:spPr>
+          <a:xfrm>
+            <a:off x="4304039" y="1260000"/>
+            <a:ext cx="3584039" cy="2340000"/>
+          </a:xfrm>
+          <a:prstGeom prst="roundRect">
+            <a:avLst/>
+          </a:prstGeom>
+          <a:solidFill>
+            <a:srgbClr val="E8F0F9"/>
+          </a:solidFill>
+          <a:ln>
+            <a:noFill/>
+          </a:ln>
+          <a:effectLst/>
+        </p:spPr>
+        <p:style>
+          <a:lnRef idx="1">
+            <a:schemeClr val="accent1"/>
+          </a:lnRef>
+          <a:fillRef idx="3">
+            <a:schemeClr val="accent1"/>
+          </a:fillRef>
+          <a:effectRef idx="2">
+            <a:schemeClr val="accent1"/>
+          </a:effectRef>
+          <a:fontRef idx="minor">
+            <a:schemeClr val="lt1"/>
+          </a:fontRef>
+        </p:style>
+        <p:txBody>
+          <a:bodyPr rtlCol="0" anchor="ctr"/>
+          <a:lstStyle/>
+          <a:p>
+            <a:pPr algn="ctr"/>
+          </a:p>
+        </p:txBody>
+      </p:sp>
+      <p:sp>
+        <p:nvSpPr>
+          <p:cNvPr id="11" name="Rectangle 10"/>
+          <p:cNvSpPr/>
+          <p:nvPr/>
+        </p:nvSpPr>
+        <p:spPr>
+          <a:xfrm>
+            <a:off x="4304039" y="1260000"/>
+            <a:ext cx="3584039" cy="125999"/>
+          </a:xfrm>
+          <a:prstGeom prst="rect">
+            <a:avLst/>
+          </a:prstGeom>
+          <a:solidFill>
+            <a:srgbClr val="E8B44F"/>
+          </a:solidFill>
+          <a:ln>
+            <a:noFill/>
+          </a:ln>
+          <a:effectLst/>
+        </p:spPr>
+        <p:style>
+          <a:lnRef idx="1">
+            <a:schemeClr val="accent1"/>
+          </a:lnRef>
+          <a:fillRef idx="3">
+            <a:schemeClr val="accent1"/>
+          </a:fillRef>
+          <a:effectRef idx="2">
+            <a:schemeClr val="accent1"/>
+          </a:effectRef>
+          <a:fontRef idx="minor">
+            <a:schemeClr val="lt1"/>
+          </a:fontRef>
+        </p:style>
+        <p:txBody>
+          <a:bodyPr rtlCol="0" anchor="ctr"/>
+          <a:lstStyle/>
+          <a:p>
+            <a:pPr algn="ctr"/>
+          </a:p>
+        </p:txBody>
+      </p:sp>
+      <p:sp>
+        <p:nvSpPr>
+          <p:cNvPr id="12" name="TextBox 11"/>
+          <p:cNvSpPr txBox="1"/>
+          <p:nvPr/>
+        </p:nvSpPr>
+        <p:spPr>
+          <a:xfrm>
+            <a:off x="4484039" y="1548000"/>
+            <a:ext cx="3224039" cy="540000"/>
+          </a:xfrm>
+          <a:prstGeom prst="rect">
+            <a:avLst/>
+          </a:prstGeom>
+          <a:noFill/>
+        </p:spPr>
+        <p:txBody>
+          <a:bodyPr wrap="square" lIns="0" rIns="0" tIns="0" bIns="0">
+            <a:spAutoFit/>
+          </a:bodyPr>
+          <a:lstStyle/>
+          <a:p>
+            <a:pPr algn="l"/>
+            <a:r>
+              <a:rPr sz="1700" b="1" i="0">
+                <a:solidFill>
+                  <a:srgbClr val="1F4E79"/>
+                </a:solidFill>
+                <a:latin typeface="Calibri"/>
+              </a:rPr>
+              <a:t>Lekka i szybka</a:t>
+            </a:r>
+          </a:p>
+        </p:txBody>
+      </p:sp>
+      <p:sp>
+        <p:nvSpPr>
+          <p:cNvPr id="13" name="TextBox 12"/>
+          <p:cNvSpPr txBox="1"/>
+          <p:nvPr/>
+        </p:nvSpPr>
+        <p:spPr>
+          <a:xfrm>
+            <a:off x="4484039" y="2160000"/>
+            <a:ext cx="3224039" cy="1368000"/>
+          </a:xfrm>
+          <a:prstGeom prst="rect">
+            <a:avLst/>
+          </a:prstGeom>
+          <a:noFill/>
+        </p:spPr>
+        <p:txBody>
+          <a:bodyPr wrap="square" lIns="0" rIns="0" tIns="0" bIns="0">
+            <a:spAutoFit/>
+          </a:bodyPr>
+          <a:lstStyle/>
+          <a:p>
+            <a:pPr algn="l"/>
+            <a:r>
+              <a:rPr sz="1300" b="0" i="0">
+                <a:solidFill>
+                  <a:srgbClr val="1A1A1A"/>
+                </a:solidFill>
+                <a:latin typeface="Calibri"/>
+              </a:rPr>
+              <a:t>Działa w zwykłej przeglądarce - nawet słabszy telefon wystarczy.</a:t>
+            </a:r>
+          </a:p>
+        </p:txBody>
+      </p:sp>
+      <p:sp>
+        <p:nvSpPr>
+          <p:cNvPr id="14" name="Rounded Rectangle 13"/>
+          <p:cNvSpPr/>
+          <p:nvPr/>
+        </p:nvSpPr>
+        <p:spPr>
+          <a:xfrm>
+            <a:off x="8068079" y="1260000"/>
+            <a:ext cx="3584039" cy="2340000"/>
+          </a:xfrm>
+          <a:prstGeom prst="roundRect">
+            <a:avLst/>
+          </a:prstGeom>
+          <a:solidFill>
+            <a:srgbClr val="E8F0F9"/>
+          </a:solidFill>
+          <a:ln>
+            <a:noFill/>
+          </a:ln>
+          <a:effectLst/>
+        </p:spPr>
+        <p:style>
+          <a:lnRef idx="1">
+            <a:schemeClr val="accent1"/>
+          </a:lnRef>
+          <a:fillRef idx="3">
+            <a:schemeClr val="accent1"/>
+          </a:fillRef>
+          <a:effectRef idx="2">
+            <a:schemeClr val="accent1"/>
+          </a:effectRef>
+          <a:fontRef idx="minor">
+            <a:schemeClr val="lt1"/>
+          </a:fontRef>
+        </p:style>
+        <p:txBody>
+          <a:bodyPr rtlCol="0" anchor="ctr"/>
+          <a:lstStyle/>
+          <a:p>
+            <a:pPr algn="ctr"/>
+          </a:p>
+        </p:txBody>
+      </p:sp>
+      <p:sp>
+        <p:nvSpPr>
+          <p:cNvPr id="15" name="Rectangle 14"/>
+          <p:cNvSpPr/>
+          <p:nvPr/>
+        </p:nvSpPr>
+        <p:spPr>
+          <a:xfrm>
+            <a:off x="8068079" y="1260000"/>
+            <a:ext cx="3584039" cy="125999"/>
+          </a:xfrm>
+          <a:prstGeom prst="rect">
+            <a:avLst/>
+          </a:prstGeom>
+          <a:solidFill>
+            <a:srgbClr val="E8B44F"/>
+          </a:solidFill>
+          <a:ln>
+            <a:noFill/>
+          </a:ln>
+          <a:effectLst/>
+        </p:spPr>
+        <p:style>
+          <a:lnRef idx="1">
+            <a:schemeClr val="accent1"/>
+          </a:lnRef>
+          <a:fillRef idx="3">
+            <a:schemeClr val="accent1"/>
+          </a:fillRef>
+          <a:effectRef idx="2">
+            <a:schemeClr val="accent1"/>
+          </a:effectRef>
+          <a:fontRef idx="minor">
+            <a:schemeClr val="lt1"/>
+          </a:fontRef>
+        </p:style>
+        <p:txBody>
+          <a:bodyPr rtlCol="0" anchor="ctr"/>
+          <a:lstStyle/>
+          <a:p>
+            <a:pPr algn="ctr"/>
+          </a:p>
+        </p:txBody>
+      </p:sp>
+      <p:sp>
+        <p:nvSpPr>
+          <p:cNvPr id="16" name="TextBox 15"/>
+          <p:cNvSpPr txBox="1"/>
+          <p:nvPr/>
+        </p:nvSpPr>
+        <p:spPr>
+          <a:xfrm>
+            <a:off x="8248079" y="1548000"/>
+            <a:ext cx="3224039" cy="540000"/>
+          </a:xfrm>
+          <a:prstGeom prst="rect">
+            <a:avLst/>
+          </a:prstGeom>
+          <a:noFill/>
+        </p:spPr>
+        <p:txBody>
+          <a:bodyPr wrap="square" lIns="0" rIns="0" tIns="0" bIns="0">
+            <a:spAutoFit/>
+          </a:bodyPr>
+          <a:lstStyle/>
+          <a:p>
+            <a:pPr algn="l"/>
+            <a:r>
+              <a:rPr sz="1700" b="1" i="0">
+                <a:solidFill>
+                  <a:srgbClr val="1F4E79"/>
+                </a:solidFill>
+                <a:latin typeface="Calibri"/>
+              </a:rPr>
+              <a:t>Dla dużej sali</a:t>
+            </a:r>
+          </a:p>
+        </p:txBody>
+      </p:sp>
+      <p:sp>
+        <p:nvSpPr>
+          <p:cNvPr id="17" name="TextBox 16"/>
+          <p:cNvSpPr txBox="1"/>
+          <p:nvPr/>
+        </p:nvSpPr>
+        <p:spPr>
+          <a:xfrm>
+            <a:off x="8248079" y="2160000"/>
+            <a:ext cx="3224039" cy="1368000"/>
+          </a:xfrm>
+          <a:prstGeom prst="rect">
+            <a:avLst/>
+          </a:prstGeom>
+          <a:noFill/>
+        </p:spPr>
+        <p:txBody>
+          <a:bodyPr wrap="square" lIns="0" rIns="0" tIns="0" bIns="0">
+            <a:spAutoFit/>
+          </a:bodyPr>
+          <a:lstStyle/>
+          <a:p>
+            <a:pPr algn="l"/>
+            <a:r>
+              <a:rPr sz="1300" b="0" i="0">
+                <a:solidFill>
+                  <a:srgbClr val="1A1A1A"/>
+                </a:solidFill>
+                <a:latin typeface="Calibri"/>
+              </a:rPr>
+              <a:t>Od kilku do kilkuset uczestników jednocześnie, bez limitów.</a:t>
+            </a:r>
+          </a:p>
+        </p:txBody>
+      </p:sp>
+      <p:sp>
+        <p:nvSpPr>
+          <p:cNvPr id="18" name="Rounded Rectangle 17"/>
+          <p:cNvSpPr/>
+          <p:nvPr/>
+        </p:nvSpPr>
+        <p:spPr>
+          <a:xfrm>
+            <a:off x="540000" y="3816000"/>
+            <a:ext cx="3584039" cy="2340000"/>
+          </a:xfrm>
+          <a:prstGeom prst="roundRect">
+            <a:avLst/>
+          </a:prstGeom>
+          <a:solidFill>
+            <a:srgbClr val="E8F0F9"/>
+          </a:solidFill>
+          <a:ln>
+            <a:noFill/>
+          </a:ln>
+          <a:effectLst/>
+        </p:spPr>
+        <p:style>
+          <a:lnRef idx="1">
+            <a:schemeClr val="accent1"/>
+          </a:lnRef>
+          <a:fillRef idx="3">
+            <a:schemeClr val="accent1"/>
+          </a:fillRef>
+          <a:effectRef idx="2">
+            <a:schemeClr val="accent1"/>
+          </a:effectRef>
+          <a:fontRef idx="minor">
+            <a:schemeClr val="lt1"/>
+          </a:fontRef>
+        </p:style>
+        <p:txBody>
+          <a:bodyPr rtlCol="0" anchor="ctr"/>
+          <a:lstStyle/>
+          <a:p>
+            <a:pPr algn="ctr"/>
+          </a:p>
+        </p:txBody>
+      </p:sp>
+      <p:sp>
+        <p:nvSpPr>
+          <p:cNvPr id="19" name="Rectangle 18"/>
+          <p:cNvSpPr/>
+          <p:nvPr/>
+        </p:nvSpPr>
+        <p:spPr>
+          <a:xfrm>
+            <a:off x="540000" y="3816000"/>
+            <a:ext cx="3584039" cy="125999"/>
+          </a:xfrm>
+          <a:prstGeom prst="rect">
+            <a:avLst/>
+          </a:prstGeom>
+          <a:solidFill>
+            <a:srgbClr val="E8B44F"/>
+          </a:solidFill>
+          <a:ln>
+            <a:noFill/>
+          </a:ln>
+          <a:effectLst/>
+        </p:spPr>
+        <p:style>
+          <a:lnRef idx="1">
+            <a:schemeClr val="accent1"/>
+          </a:lnRef>
+          <a:fillRef idx="3">
+            <a:schemeClr val="accent1"/>
+          </a:fillRef>
+          <a:effectRef idx="2">
+            <a:schemeClr val="accent1"/>
+          </a:effectRef>
+          <a:fontRef idx="minor">
+            <a:schemeClr val="lt1"/>
+          </a:fontRef>
+        </p:style>
+        <p:txBody>
+          <a:bodyPr rtlCol="0" anchor="ctr"/>
+          <a:lstStyle/>
+          <a:p>
+            <a:pPr algn="ctr"/>
+          </a:p>
+        </p:txBody>
+      </p:sp>
+      <p:sp>
+        <p:nvSpPr>
+          <p:cNvPr id="20" name="TextBox 19"/>
+          <p:cNvSpPr txBox="1"/>
+          <p:nvPr/>
+        </p:nvSpPr>
+        <p:spPr>
+          <a:xfrm>
+            <a:off x="720000" y="4104000"/>
+            <a:ext cx="3224039" cy="540000"/>
+          </a:xfrm>
+          <a:prstGeom prst="rect">
+            <a:avLst/>
+          </a:prstGeom>
+          <a:noFill/>
+        </p:spPr>
+        <p:txBody>
+          <a:bodyPr wrap="square" lIns="0" rIns="0" tIns="0" bIns="0">
+            <a:spAutoFit/>
+          </a:bodyPr>
+          <a:lstStyle/>
+          <a:p>
+            <a:pPr algn="l"/>
+            <a:r>
+              <a:rPr sz="1700" b="1" i="0">
+                <a:solidFill>
+                  <a:srgbClr val="1F4E79"/>
+                </a:solidFill>
+                <a:latin typeface="Calibri"/>
+              </a:rPr>
+              <a:t>Wasze dane zostają u Was</a:t>
+            </a:r>
+          </a:p>
+        </p:txBody>
+      </p:sp>
+      <p:sp>
+        <p:nvSpPr>
+          <p:cNvPr id="21" name="TextBox 20"/>
+          <p:cNvSpPr txBox="1"/>
+          <p:nvPr/>
+        </p:nvSpPr>
+        <p:spPr>
+          <a:xfrm>
+            <a:off x="720000" y="4716000"/>
+            <a:ext cx="3224039" cy="1368000"/>
+          </a:xfrm>
+          <a:prstGeom prst="rect">
+            <a:avLst/>
+          </a:prstGeom>
+          <a:noFill/>
+        </p:spPr>
+        <p:txBody>
+          <a:bodyPr wrap="square" lIns="0" rIns="0" tIns="0" bIns="0">
+            <a:spAutoFit/>
+          </a:bodyPr>
+          <a:lstStyle/>
+          <a:p>
+            <a:pPr algn="l"/>
+            <a:r>
+              <a:rPr sz="1300" b="0" i="0">
+                <a:solidFill>
+                  <a:srgbClr val="1A1A1A"/>
+                </a:solidFill>
+                <a:latin typeface="Calibri"/>
+              </a:rPr>
+              <a:t>Quizy i wyniki nie wędrują do żadnej obcej chmury.</a:t>
+            </a:r>
+          </a:p>
+        </p:txBody>
+      </p:sp>
+      <p:sp>
+        <p:nvSpPr>
+          <p:cNvPr id="22" name="Rounded Rectangle 21"/>
+          <p:cNvSpPr/>
+          <p:nvPr/>
+        </p:nvSpPr>
+        <p:spPr>
+          <a:xfrm>
+            <a:off x="4304039" y="3816000"/>
+            <a:ext cx="3584039" cy="2340000"/>
+          </a:xfrm>
+          <a:prstGeom prst="roundRect">
+            <a:avLst/>
+          </a:prstGeom>
+          <a:solidFill>
+            <a:srgbClr val="E8F0F9"/>
+          </a:solidFill>
+          <a:ln>
+            <a:noFill/>
+          </a:ln>
+          <a:effectLst/>
+        </p:spPr>
+        <p:style>
+          <a:lnRef idx="1">
+            <a:schemeClr val="accent1"/>
+          </a:lnRef>
+          <a:fillRef idx="3">
+            <a:schemeClr val="accent1"/>
+          </a:fillRef>
+          <a:effectRef idx="2">
+            <a:schemeClr val="accent1"/>
+          </a:effectRef>
+          <a:fontRef idx="minor">
+            <a:schemeClr val="lt1"/>
+          </a:fontRef>
+        </p:style>
+        <p:txBody>
+          <a:bodyPr rtlCol="0" anchor="ctr"/>
+          <a:lstStyle/>
+          <a:p>
+            <a:pPr algn="ctr"/>
+          </a:p>
+        </p:txBody>
+      </p:sp>
+      <p:sp>
+        <p:nvSpPr>
+          <p:cNvPr id="23" name="Rectangle 22"/>
+          <p:cNvSpPr/>
+          <p:nvPr/>
+        </p:nvSpPr>
+        <p:spPr>
+          <a:xfrm>
+            <a:off x="4304039" y="3816000"/>
+            <a:ext cx="3584039" cy="125999"/>
+          </a:xfrm>
+          <a:prstGeom prst="rect">
+            <a:avLst/>
+          </a:prstGeom>
+          <a:solidFill>
+            <a:srgbClr val="E8B44F"/>
+          </a:solidFill>
+          <a:ln>
+            <a:noFill/>
+          </a:ln>
+          <a:effectLst/>
+        </p:spPr>
+        <p:style>
+          <a:lnRef idx="1">
+            <a:schemeClr val="accent1"/>
+          </a:lnRef>
+          <a:fillRef idx="3">
+            <a:schemeClr val="accent1"/>
+          </a:fillRef>
+          <a:effectRef idx="2">
+            <a:schemeClr val="accent1"/>
+          </a:effectRef>
+          <a:fontRef idx="minor">
+            <a:schemeClr val="lt1"/>
+          </a:fontRef>
+        </p:style>
+        <p:txBody>
+          <a:bodyPr rtlCol="0" anchor="ctr"/>
+          <a:lstStyle/>
+          <a:p>
+            <a:pPr algn="ctr"/>
+          </a:p>
+        </p:txBody>
+      </p:sp>
+      <p:sp>
+        <p:nvSpPr>
+          <p:cNvPr id="24" name="TextBox 23"/>
+          <p:cNvSpPr txBox="1"/>
+          <p:nvPr/>
+        </p:nvSpPr>
+        <p:spPr>
+          <a:xfrm>
+            <a:off x="4484039" y="4104000"/>
+            <a:ext cx="3224039" cy="540000"/>
+          </a:xfrm>
+          <a:prstGeom prst="rect">
+            <a:avLst/>
+          </a:prstGeom>
+          <a:noFill/>
+        </p:spPr>
+        <p:txBody>
+          <a:bodyPr wrap="square" lIns="0" rIns="0" tIns="0" bIns="0">
+            <a:spAutoFit/>
+          </a:bodyPr>
+          <a:lstStyle/>
+          <a:p>
+            <a:pPr algn="l"/>
+            <a:r>
+              <a:rPr sz="1700" b="1" i="0">
+                <a:solidFill>
+                  <a:srgbClr val="1F4E79"/>
+                </a:solidFill>
+                <a:latin typeface="Calibri"/>
+              </a:rPr>
+              <a:t>Pełna kontrola w trakcie</a:t>
+            </a:r>
+          </a:p>
+        </p:txBody>
+      </p:sp>
+      <p:sp>
+        <p:nvSpPr>
+          <p:cNvPr id="25" name="TextBox 24"/>
+          <p:cNvSpPr txBox="1"/>
+          <p:nvPr/>
+        </p:nvSpPr>
+        <p:spPr>
+          <a:xfrm>
+            <a:off x="4484039" y="4716000"/>
+            <a:ext cx="3224039" cy="1368000"/>
+          </a:xfrm>
+          <a:prstGeom prst="rect">
+            <a:avLst/>
+          </a:prstGeom>
+          <a:noFill/>
+        </p:spPr>
+        <p:txBody>
+          <a:bodyPr wrap="square" lIns="0" rIns="0" tIns="0" bIns="0">
+            <a:spAutoFit/>
+          </a:bodyPr>
+          <a:lstStyle/>
+          <a:p>
+            <a:pPr algn="l"/>
+            <a:r>
+              <a:rPr sz="1300" b="0" i="0">
+                <a:solidFill>
+                  <a:srgbClr val="1A1A1A"/>
+                </a:solidFill>
+                <a:latin typeface="Calibri"/>
+              </a:rPr>
+              <a:t>Widzicie kto dołączył, kto odpowiedział, możecie zablokować lub zakończyć.</a:t>
+            </a:r>
+          </a:p>
+        </p:txBody>
+      </p:sp>
+      <p:sp>
+        <p:nvSpPr>
+          <p:cNvPr id="26" name="Rounded Rectangle 25"/>
+          <p:cNvSpPr/>
+          <p:nvPr/>
+        </p:nvSpPr>
+        <p:spPr>
+          <a:xfrm>
+            <a:off x="8068079" y="3816000"/>
+            <a:ext cx="3584039" cy="2340000"/>
+          </a:xfrm>
+          <a:prstGeom prst="roundRect">
+            <a:avLst/>
+          </a:prstGeom>
+          <a:solidFill>
+            <a:srgbClr val="E8F0F9"/>
+          </a:solidFill>
+          <a:ln>
+            <a:noFill/>
+          </a:ln>
+          <a:effectLst/>
+        </p:spPr>
+        <p:style>
+          <a:lnRef idx="1">
+            <a:schemeClr val="accent1"/>
+          </a:lnRef>
+          <a:fillRef idx="3">
+            <a:schemeClr val="accent1"/>
+          </a:fillRef>
+          <a:effectRef idx="2">
+            <a:schemeClr val="accent1"/>
+          </a:effectRef>
+          <a:fontRef idx="minor">
+            <a:schemeClr val="lt1"/>
+          </a:fontRef>
+        </p:style>
+        <p:txBody>
+          <a:bodyPr rtlCol="0" anchor="ctr"/>
+          <a:lstStyle/>
+          <a:p>
+            <a:pPr algn="ctr"/>
+          </a:p>
+        </p:txBody>
+      </p:sp>
+      <p:sp>
+        <p:nvSpPr>
+          <p:cNvPr id="27" name="Rectangle 26"/>
+          <p:cNvSpPr/>
+          <p:nvPr/>
+        </p:nvSpPr>
+        <p:spPr>
+          <a:xfrm>
+            <a:off x="8068079" y="3816000"/>
+            <a:ext cx="3584039" cy="125999"/>
+          </a:xfrm>
+          <a:prstGeom prst="rect">
+            <a:avLst/>
+          </a:prstGeom>
+          <a:solidFill>
+            <a:srgbClr val="E8B44F"/>
+          </a:solidFill>
+          <a:ln>
+            <a:noFill/>
+          </a:ln>
+          <a:effectLst/>
+        </p:spPr>
+        <p:style>
+          <a:lnRef idx="1">
+            <a:schemeClr val="accent1"/>
+          </a:lnRef>
+          <a:fillRef idx="3">
+            <a:schemeClr val="accent1"/>
+          </a:fillRef>
+          <a:effectRef idx="2">
+            <a:schemeClr val="accent1"/>
+          </a:effectRef>
+          <a:fontRef idx="minor">
+            <a:schemeClr val="lt1"/>
+          </a:fontRef>
+        </p:style>
+        <p:txBody>
+          <a:bodyPr rtlCol="0" anchor="ctr"/>
+          <a:lstStyle/>
+          <a:p>
+            <a:pPr algn="ctr"/>
+          </a:p>
+        </p:txBody>
+      </p:sp>
+      <p:sp>
+        <p:nvSpPr>
+          <p:cNvPr id="28" name="TextBox 27"/>
+          <p:cNvSpPr txBox="1"/>
+          <p:nvPr/>
+        </p:nvSpPr>
+        <p:spPr>
+          <a:xfrm>
+            <a:off x="8248079" y="4104000"/>
+            <a:ext cx="3224039" cy="540000"/>
+          </a:xfrm>
+          <a:prstGeom prst="rect">
+            <a:avLst/>
+          </a:prstGeom>
+          <a:noFill/>
+        </p:spPr>
+        <p:txBody>
+          <a:bodyPr wrap="square" lIns="0" rIns="0" tIns="0" bIns="0">
+            <a:spAutoFit/>
+          </a:bodyPr>
+          <a:lstStyle/>
+          <a:p>
+            <a:pPr algn="l"/>
+            <a:r>
+              <a:rPr sz="1700" b="1" i="0">
+                <a:solidFill>
+                  <a:srgbClr val="1F4E79"/>
+                </a:solidFill>
+                <a:latin typeface="Calibri"/>
+              </a:rPr>
+              <a:t>Łatwe przenoszenie</a:t>
+            </a:r>
+          </a:p>
+        </p:txBody>
+      </p:sp>
+      <p:sp>
+        <p:nvSpPr>
+          <p:cNvPr id="29" name="TextBox 28"/>
+          <p:cNvSpPr txBox="1"/>
+          <p:nvPr/>
+        </p:nvSpPr>
+        <p:spPr>
+          <a:xfrm>
+            <a:off x="8248079" y="4716000"/>
+            <a:ext cx="3224039" cy="1368000"/>
+          </a:xfrm>
+          <a:prstGeom prst="rect">
+            <a:avLst/>
+          </a:prstGeom>
+          <a:noFill/>
+        </p:spPr>
+        <p:txBody>
+          <a:bodyPr wrap="square" lIns="0" rIns="0" tIns="0" bIns="0">
+            <a:spAutoFit/>
+          </a:bodyPr>
+          <a:lstStyle/>
+          <a:p>
+            <a:pPr algn="l"/>
+            <a:r>
+              <a:rPr sz="1300" b="0" i="0">
+                <a:solidFill>
+                  <a:srgbClr val="1A1A1A"/>
+                </a:solidFill>
+                <a:latin typeface="Calibri"/>
+              </a:rPr>
+              <a:t>Cały quiz w jednym pliku - między komputerami, między prowadzącymi.</a:t>
+            </a:r>
+          </a:p>
+        </p:txBody>
+      </p:sp>
+    </p:spTree>
+  </p:cSld>
+  <p:clrMapOvr>
+    <a:masterClrMapping/>
+  </p:clrMapOvr>
+</p:sld>
+</file>
+
+<file path=ppt/slides/slide23.xml><?xml version="1.0" encoding="utf-8"?>
 <p:sld xmlns:a="http://schemas.openxmlformats.org/drawingml/2006/main" xmlns:p="http://schemas.openxmlformats.org/presentationml/2006/main" xmlns:r="http://schemas.openxmlformats.org/officeDocument/2006/relationships">
   <p:cSld>
     <p:bg>
@@ -8998,7 +9850,7 @@
                 </a:solidFill>
                 <a:latin typeface="Calibri"/>
               </a:rPr>
-              <a:t>3 / 21</a:t>
+              <a:t>3 / 23</a:t>
             </a:r>
           </a:p>
         </p:txBody>
@@ -9364,7 +10216,7 @@
                 </a:solidFill>
                 <a:latin typeface="Calibri"/>
               </a:rPr>
-              <a:t>4 / 21</a:t>
+              <a:t>4 / 23</a:t>
             </a:r>
           </a:p>
         </p:txBody>
@@ -9730,7 +10582,7 @@
                 </a:solidFill>
                 <a:latin typeface="Calibri"/>
               </a:rPr>
-              <a:t>5 / 21</a:t>
+              <a:t>5 / 23</a:t>
             </a:r>
           </a:p>
         </p:txBody>
@@ -9833,7 +10685,7 @@
                 </a:solidFill>
                 <a:latin typeface="Calibri"/>
               </a:rPr>
-              <a:t>Tytuł, opis, autor, opcjonalne tagi, limit czasu i inne opcje gry — wszystko w jednym miejscu.</a:t>
+              <a:t>Tytuł, opis, autor, opcjonalne tagi, limit czasu i inne opcje gry - wszystko w jednym miejscu.</a:t>
             </a:r>
           </a:p>
         </p:txBody>
@@ -10096,7 +10948,7 @@
                 </a:solidFill>
                 <a:latin typeface="Calibri"/>
               </a:rPr>
-              <a:t>6 / 21</a:t>
+              <a:t>6 / 23</a:t>
             </a:r>
           </a:p>
         </p:txBody>
@@ -10462,7 +11314,7 @@
                 </a:solidFill>
                 <a:latin typeface="Calibri"/>
               </a:rPr>
-              <a:t>7 / 21</a:t>
+              <a:t>7 / 23</a:t>
             </a:r>
           </a:p>
         </p:txBody>
@@ -10828,7 +11680,7 @@
                 </a:solidFill>
                 <a:latin typeface="Calibri"/>
               </a:rPr>
-              <a:t>8 / 21</a:t>
+              <a:t>8 / 23</a:t>
             </a:r>
           </a:p>
         </p:txBody>
@@ -10931,7 +11783,7 @@
                 </a:solidFill>
                 <a:latin typeface="Calibri"/>
               </a:rPr>
-              <a:t>W jednym quizie można mieszać wszystkie cztery typy pytań — i zapisać jednym kliknięciem.</a:t>
+              <a:t>W jednym quizie można mieszać różne typy pytań i zapisać go jednym kliknięciem.</a:t>
             </a:r>
           </a:p>
         </p:txBody>
@@ -11115,7 +11967,7 @@
                 </a:solidFill>
                 <a:latin typeface="Calibri"/>
               </a:rPr>
-              <a:t>9 / 21</a:t>
+              <a:t>9 / 23</a:t>
             </a:r>
           </a:p>
         </p:txBody>
@@ -11356,7 +12208,7 @@
                 </a:solidFill>
                 <a:latin typeface="Calibri"/>
               </a:rPr>
-              <a:t>Klasyka. W edytorze wpisujesz pytanie i kilka odpowiedzi — zaznaczasz jedną poprawną. Uczestnik wybiera jedną opcję i zatwierdza.</a:t>
+              <a:t>Klasyka. W edytorze wpisujesz pytanie i kilka odpowiedzi - zaznaczasz jedną poprawną. Uczestnik wybiera jedną opcję i zatwierdza.</a:t>
             </a:r>
           </a:p>
         </p:txBody>

</xml_diff>